<commit_message>
plot, rank, single dataframe for disparity done
</commit_message>
<xml_diff>
--- a/11.Presenttaions/big-cities-transport.pptx
+++ b/11.Presenttaions/big-cities-transport.pptx
@@ -5,7 +5,7 @@
     <p:sldMasterId id="2147483648" r:id="rId1"/>
   </p:sldMasterIdLst>
   <p:notesMasterIdLst>
-    <p:notesMasterId r:id="rId25"/>
+    <p:notesMasterId r:id="rId29"/>
   </p:notesMasterIdLst>
   <p:sldIdLst>
     <p:sldId id="257" r:id="rId2"/>
@@ -29,8 +29,12 @@
     <p:sldId id="270" r:id="rId20"/>
     <p:sldId id="262" r:id="rId21"/>
     <p:sldId id="263" r:id="rId22"/>
-    <p:sldId id="264" r:id="rId23"/>
-    <p:sldId id="265" r:id="rId24"/>
+    <p:sldId id="288" r:id="rId23"/>
+    <p:sldId id="290" r:id="rId24"/>
+    <p:sldId id="289" r:id="rId25"/>
+    <p:sldId id="291" r:id="rId26"/>
+    <p:sldId id="264" r:id="rId27"/>
+    <p:sldId id="265" r:id="rId28"/>
   </p:sldIdLst>
   <p:sldSz cx="12192000" cy="6858000"/>
   <p:notesSz cx="6858000" cy="9144000"/>
@@ -219,7 +223,7 @@
           <a:p>
             <a:fld id="{E0227317-6136-4B22-B169-340711FF5F77}" type="datetimeFigureOut">
               <a:rPr lang="fr-BE" smtClean="0"/>
-              <a:t>10-10-23</a:t>
+              <a:t>29-10-23</a:t>
             </a:fld>
             <a:endParaRPr lang="fr-BE"/>
           </a:p>
@@ -4132,10 +4136,49 @@
           <a:bodyPr/>
           <a:lstStyle/>
           <a:p>
+            <a:pPr marL="171450" indent="-171450">
+              <a:buFont typeface="Wingdings" panose="05000000000000000000" pitchFamily="2" charset="2"/>
+              <a:buChar char="à"/>
+            </a:pPr>
+            <a:r>
+              <a:rPr lang="en-US" dirty="0">
+                <a:sym typeface="Wingdings" panose="05000000000000000000" pitchFamily="2" charset="2"/>
+              </a:rPr>
+              <a:t>Operational: Speed &amp; Frequency</a:t>
+            </a:r>
+          </a:p>
+          <a:p>
+            <a:pPr marL="171450" indent="-171450">
+              <a:buFontTx/>
+              <a:buChar char="-"/>
+            </a:pPr>
+            <a:r>
+              <a:rPr lang="en-US" dirty="0">
+                <a:sym typeface="Wingdings" panose="05000000000000000000" pitchFamily="2" charset="2"/>
+              </a:rPr>
+              <a:t>Histogram (charts) weight</a:t>
+            </a:r>
+          </a:p>
+          <a:p>
+            <a:pPr marL="171450" indent="-171450">
+              <a:buFontTx/>
+              <a:buChar char="-"/>
+            </a:pPr>
+            <a:r>
+              <a:rPr lang="en-US" dirty="0">
+                <a:sym typeface="Wingdings" panose="05000000000000000000" pitchFamily="2" charset="2"/>
+              </a:rPr>
+              <a:t>Maps (Networkx)</a:t>
+            </a:r>
+          </a:p>
+          <a:p>
             <a:pPr marL="0" indent="0">
-              <a:buNone/>
-            </a:pPr>
-            <a:endParaRPr lang="en-US" dirty="0"/>
+              <a:buFontTx/>
+              <a:buNone/>
+            </a:pPr>
+            <a:endParaRPr lang="en-US" dirty="0">
+              <a:sym typeface="Wingdings" panose="05000000000000000000" pitchFamily="2" charset="2"/>
+            </a:endParaRPr>
           </a:p>
           <a:p>
             <a:pPr marL="0" marR="0" lvl="0" indent="0" algn="l" defTabSz="914400" rtl="0" eaLnBrk="1" fontAlgn="auto" latinLnBrk="0" hangingPunct="1">
@@ -4156,108 +4199,47 @@
               <a:defRPr/>
             </a:pPr>
             <a:r>
-              <a:rPr lang="en-US" dirty="0"/>
-              <a:t>1) </a:t>
-            </a:r>
-            <a:r>
               <a:rPr lang="en-US" dirty="0">
                 <a:sym typeface="Wingdings" panose="05000000000000000000" pitchFamily="2" charset="2"/>
               </a:rPr>
-              <a:t>Interconnect all possible modes of transport including bikes and walks.</a:t>
-            </a:r>
-            <a:endParaRPr lang="en-US" dirty="0"/>
-          </a:p>
-          <a:p>
-            <a:pPr marL="0" indent="0">
-              <a:buNone/>
-            </a:pPr>
-            <a:endParaRPr lang="en-US" dirty="0"/>
-          </a:p>
-          <a:p>
-            <a:pPr marL="0" indent="0">
-              <a:buNone/>
-            </a:pPr>
-            <a:endParaRPr lang="en-US" dirty="0"/>
-          </a:p>
-          <a:p>
-            <a:pPr marL="0" indent="0">
-              <a:buNone/>
-            </a:pPr>
-            <a:r>
-              <a:rPr lang="en-US" dirty="0"/>
-              <a:t>2) Use ML models for predictions of:</a:t>
-            </a:r>
-          </a:p>
-          <a:p>
-            <a:pPr marL="228600" indent="-228600">
-              <a:buAutoNum type="arabicParenR"/>
-            </a:pPr>
-            <a:endParaRPr lang="en-US" dirty="0"/>
+              <a:t> Traffic</a:t>
+            </a:r>
           </a:p>
           <a:p>
             <a:pPr marL="171450" indent="-171450">
-              <a:buFont typeface="Wingdings" panose="05000000000000000000" pitchFamily="2" charset="2"/>
-              <a:buChar char="à"/>
-            </a:pPr>
-            <a:r>
-              <a:rPr lang="en-US" dirty="0"/>
-              <a:t>TRAFFIC: Passenger flow: </a:t>
-            </a:r>
-            <a:r>
-              <a:rPr lang="en-US" b="0" i="0" dirty="0">
-                <a:solidFill>
-                  <a:srgbClr val="24292F"/>
-                </a:solidFill>
-                <a:effectLst/>
-                <a:latin typeface="-apple-system"/>
+              <a:buFontTx/>
+              <a:buChar char="-"/>
+            </a:pPr>
+            <a:r>
+              <a:rPr lang="en-US" dirty="0">
+                <a:sym typeface="Wingdings" panose="05000000000000000000" pitchFamily="2" charset="2"/>
               </a:rPr>
-              <a:t>From network lens (keeping passenger anonymity) , use more data (daily events) to more accurately understand why traffic is generated in each segments;</a:t>
+              <a:t>Enter/Exists in stations (Networkx)</a:t>
             </a:r>
           </a:p>
           <a:p>
             <a:pPr marL="171450" indent="-171450">
-              <a:buFont typeface="Wingdings" panose="05000000000000000000" pitchFamily="2" charset="2"/>
-              <a:buChar char="à"/>
-            </a:pPr>
-            <a:endParaRPr lang="en-US" b="0" i="0" dirty="0">
-              <a:solidFill>
-                <a:srgbClr val="24292F"/>
-              </a:solidFill>
-              <a:effectLst/>
-              <a:latin typeface="-apple-system"/>
+              <a:buFontTx/>
+              <a:buChar char="-"/>
+            </a:pPr>
+            <a:r>
+              <a:rPr lang="en-US" dirty="0">
+                <a:sym typeface="Wingdings" panose="05000000000000000000" pitchFamily="2" charset="2"/>
+              </a:rPr>
+              <a:t>Load in segments (Networkx)</a:t>
+            </a:r>
+          </a:p>
+          <a:p>
+            <a:pPr marL="171450" indent="-171450">
+              <a:buFontTx/>
+              <a:buChar char="-"/>
+            </a:pPr>
+            <a:endParaRPr lang="en-US" dirty="0">
+              <a:sym typeface="Wingdings" panose="05000000000000000000" pitchFamily="2" charset="2"/>
             </a:endParaRPr>
           </a:p>
           <a:p>
-            <a:pPr marL="171450" indent="-171450">
-              <a:buFont typeface="Wingdings" panose="05000000000000000000" pitchFamily="2" charset="2"/>
-              <a:buChar char="à"/>
-            </a:pPr>
-            <a:r>
-              <a:rPr lang="en-US" b="0" i="0" dirty="0">
-                <a:solidFill>
-                  <a:srgbClr val="24292F"/>
-                </a:solidFill>
-                <a:effectLst/>
-                <a:latin typeface="-apple-system"/>
-              </a:rPr>
-              <a:t>OPEX: Predict disruptions and its impact considering forecasted passenger traffic to optimize maintenance planning.</a:t>
-            </a:r>
-          </a:p>
-          <a:p>
-            <a:pPr marL="171450" indent="-171450">
-              <a:buFont typeface="Wingdings" panose="05000000000000000000" pitchFamily="2" charset="2"/>
-              <a:buChar char="à"/>
-            </a:pPr>
-            <a:endParaRPr lang="en-US" b="0" i="0" dirty="0">
-              <a:solidFill>
-                <a:srgbClr val="24292F"/>
-              </a:solidFill>
-              <a:effectLst/>
-              <a:latin typeface="-apple-system"/>
-            </a:endParaRPr>
-          </a:p>
-          <a:p>
-            <a:pPr marL="171450" marR="0" lvl="0" indent="-171450" algn="l" defTabSz="914400" rtl="0" eaLnBrk="1" fontAlgn="auto" latinLnBrk="0" hangingPunct="1">
+            <a:pPr marL="0" marR="0" lvl="0" indent="0" algn="l" defTabSz="914400" rtl="0" eaLnBrk="1" fontAlgn="auto" latinLnBrk="0" hangingPunct="1">
               <a:lnSpc>
                 <a:spcPct val="100000"/>
               </a:lnSpc>
@@ -4269,102 +4251,75 @@
               </a:spcAft>
               <a:buClrTx/>
               <a:buSzTx/>
-              <a:buFont typeface="Wingdings" panose="05000000000000000000" pitchFamily="2" charset="2"/>
-              <a:buChar char="à"/>
+              <a:buFontTx/>
+              <a:buNone/>
               <a:tabLst/>
               <a:defRPr/>
             </a:pPr>
             <a:r>
-              <a:rPr lang="en-US" b="0" i="0" dirty="0">
-                <a:solidFill>
-                  <a:srgbClr val="24292F"/>
-                </a:solidFill>
-                <a:effectLst/>
-                <a:latin typeface="-apple-system"/>
+              <a:rPr lang="en-US" dirty="0">
+                <a:sym typeface="Wingdings" panose="05000000000000000000" pitchFamily="2" charset="2"/>
               </a:rPr>
-              <a:t>Create a timetable dynamically tailored that optimize infra-structure towards the commuters needs.</a:t>
+              <a:t> User importance:</a:t>
             </a:r>
           </a:p>
           <a:p>
             <a:pPr marL="171450" indent="-171450">
-              <a:buFont typeface="Wingdings" panose="05000000000000000000" pitchFamily="2" charset="2"/>
-              <a:buChar char="à"/>
-            </a:pPr>
-            <a:endParaRPr lang="en-US" b="0" i="0" dirty="0">
-              <a:solidFill>
-                <a:srgbClr val="24292F"/>
-              </a:solidFill>
-              <a:effectLst/>
-              <a:latin typeface="-apple-system"/>
+              <a:buFontTx/>
+              <a:buChar char="-"/>
+            </a:pPr>
+            <a:r>
+              <a:rPr lang="en-US" dirty="0">
+                <a:sym typeface="Wingdings" panose="05000000000000000000" pitchFamily="2" charset="2"/>
+              </a:rPr>
+              <a:t>Disparity ranking comparison</a:t>
+            </a:r>
+          </a:p>
+          <a:p>
+            <a:pPr marL="171450" indent="-171450">
+              <a:buFontTx/>
+              <a:buChar char="-"/>
+            </a:pPr>
+            <a:endParaRPr lang="en-US" dirty="0">
+              <a:sym typeface="Wingdings" panose="05000000000000000000" pitchFamily="2" charset="2"/>
             </a:endParaRPr>
           </a:p>
           <a:p>
+            <a:pPr marL="0" marR="0" lvl="0" indent="0" algn="l" defTabSz="914400" rtl="0" eaLnBrk="1" fontAlgn="auto" latinLnBrk="0" hangingPunct="1">
+              <a:lnSpc>
+                <a:spcPct val="100000"/>
+              </a:lnSpc>
+              <a:spcBef>
+                <a:spcPts val="0"/>
+              </a:spcBef>
+              <a:spcAft>
+                <a:spcPts val="0"/>
+              </a:spcAft>
+              <a:buClrTx/>
+              <a:buSzTx/>
+              <a:buFontTx/>
+              <a:buNone/>
+              <a:tabLst/>
+              <a:defRPr/>
+            </a:pPr>
+            <a:r>
+              <a:rPr lang="en-US" dirty="0">
+                <a:sym typeface="Wingdings" panose="05000000000000000000" pitchFamily="2" charset="2"/>
+              </a:rPr>
+              <a:t> Collective importance:</a:t>
+            </a:r>
+          </a:p>
+          <a:p>
             <a:pPr marL="171450" indent="-171450">
-              <a:buFont typeface="Wingdings" panose="05000000000000000000" pitchFamily="2" charset="2"/>
-              <a:buChar char="à"/>
-            </a:pPr>
-            <a:r>
-              <a:rPr lang="en-US" b="0" i="0" dirty="0">
-                <a:solidFill>
-                  <a:srgbClr val="24292F"/>
-                </a:solidFill>
-                <a:effectLst/>
-                <a:latin typeface="-apple-system"/>
+              <a:buFontTx/>
+              <a:buChar char="-"/>
+            </a:pPr>
+            <a:r>
+              <a:rPr lang="en-US" dirty="0">
+                <a:sym typeface="Wingdings" panose="05000000000000000000" pitchFamily="2" charset="2"/>
               </a:rPr>
-              <a:t>CAPEX: More maintenance, less disruptions, less need for redundancy and more investment express lanes (study of origin and destination). </a:t>
-            </a:r>
-          </a:p>
-          <a:p>
-            <a:pPr marL="171450" indent="-171450">
-              <a:buFont typeface="Wingdings" panose="05000000000000000000" pitchFamily="2" charset="2"/>
-              <a:buChar char="à"/>
-            </a:pPr>
-            <a:endParaRPr lang="en-US" b="0" i="0" dirty="0">
-              <a:solidFill>
-                <a:srgbClr val="24292F"/>
-              </a:solidFill>
-              <a:effectLst/>
-              <a:latin typeface="-apple-system"/>
-            </a:endParaRPr>
-          </a:p>
-          <a:p>
-            <a:pPr marL="171450" indent="-171450">
-              <a:buFont typeface="Wingdings" panose="05000000000000000000" pitchFamily="2" charset="2"/>
-              <a:buChar char="à"/>
-            </a:pPr>
-            <a:endParaRPr lang="en-US" b="0" i="0" dirty="0">
-              <a:solidFill>
-                <a:srgbClr val="24292F"/>
-              </a:solidFill>
-              <a:effectLst/>
-              <a:latin typeface="-apple-system"/>
-            </a:endParaRPr>
-          </a:p>
-          <a:p>
-            <a:pPr marL="0" indent="0">
-              <a:buFont typeface="Wingdings" panose="05000000000000000000" pitchFamily="2" charset="2"/>
-              <a:buNone/>
-            </a:pPr>
-            <a:endParaRPr lang="en-US" b="0" i="0" dirty="0">
-              <a:solidFill>
-                <a:srgbClr val="24292F"/>
-              </a:solidFill>
-              <a:effectLst/>
-              <a:latin typeface="-apple-system"/>
-            </a:endParaRPr>
-          </a:p>
-          <a:p>
-            <a:pPr marL="171450" indent="-171450">
-              <a:buFont typeface="Wingdings" panose="05000000000000000000" pitchFamily="2" charset="2"/>
-              <a:buChar char="à"/>
-            </a:pPr>
-            <a:endParaRPr lang="en-US" b="0" i="0" dirty="0">
-              <a:solidFill>
-                <a:srgbClr val="24292F"/>
-              </a:solidFill>
-              <a:effectLst/>
-              <a:latin typeface="-apple-system"/>
-            </a:endParaRPr>
+              <a:t>Distress ranking comparison</a:t>
+            </a:r>
           </a:p>
         </p:txBody>
       </p:sp>
@@ -4394,7 +4349,7 @@
     </p:spTree>
     <p:extLst>
       <p:ext uri="{BB962C8B-B14F-4D97-AF65-F5344CB8AC3E}">
-        <p14:creationId xmlns:p14="http://schemas.microsoft.com/office/powerpoint/2010/main" val="2618829657"/>
+        <p14:creationId xmlns:p14="http://schemas.microsoft.com/office/powerpoint/2010/main" val="2407261714"/>
       </p:ext>
     </p:extLst>
   </p:cSld>
@@ -4448,10 +4403,49 @@
           <a:bodyPr/>
           <a:lstStyle/>
           <a:p>
-            <a:r>
-              <a:rPr lang="en-US" dirty="0"/>
-              <a:t>What is a efficient network = minimizes travel time and costs (vehicles, energy, emissions, price) assuring passenger “comfort” and “prompt mobility”.</a:t>
-            </a:r>
+            <a:pPr marL="171450" indent="-171450">
+              <a:buFont typeface="Wingdings" panose="05000000000000000000" pitchFamily="2" charset="2"/>
+              <a:buChar char="à"/>
+            </a:pPr>
+            <a:r>
+              <a:rPr lang="en-US" dirty="0">
+                <a:sym typeface="Wingdings" panose="05000000000000000000" pitchFamily="2" charset="2"/>
+              </a:rPr>
+              <a:t>Operational: Speed &amp; Frequency</a:t>
+            </a:r>
+          </a:p>
+          <a:p>
+            <a:pPr marL="171450" indent="-171450">
+              <a:buFontTx/>
+              <a:buChar char="-"/>
+            </a:pPr>
+            <a:r>
+              <a:rPr lang="en-US" dirty="0">
+                <a:sym typeface="Wingdings" panose="05000000000000000000" pitchFamily="2" charset="2"/>
+              </a:rPr>
+              <a:t>Histogram (charts) weight</a:t>
+            </a:r>
+          </a:p>
+          <a:p>
+            <a:pPr marL="171450" indent="-171450">
+              <a:buFontTx/>
+              <a:buChar char="-"/>
+            </a:pPr>
+            <a:r>
+              <a:rPr lang="en-US" dirty="0">
+                <a:sym typeface="Wingdings" panose="05000000000000000000" pitchFamily="2" charset="2"/>
+              </a:rPr>
+              <a:t>Maps (Networkx)</a:t>
+            </a:r>
+          </a:p>
+          <a:p>
+            <a:pPr marL="0" indent="0">
+              <a:buFontTx/>
+              <a:buNone/>
+            </a:pPr>
+            <a:endParaRPr lang="en-US" dirty="0">
+              <a:sym typeface="Wingdings" panose="05000000000000000000" pitchFamily="2" charset="2"/>
+            </a:endParaRPr>
           </a:p>
           <a:p>
             <a:pPr marL="0" marR="0" lvl="0" indent="0" algn="l" defTabSz="914400" rtl="0" eaLnBrk="1" fontAlgn="auto" latinLnBrk="0" hangingPunct="1">
@@ -4471,67 +4465,128 @@
               <a:tabLst/>
               <a:defRPr/>
             </a:pPr>
-            <a:endParaRPr lang="en-US" dirty="0"/>
-          </a:p>
-          <a:p>
-            <a:r>
-              <a:rPr lang="en-US" dirty="0"/>
-              <a:t>It is important to mention that a more efficient network inherently requires more maintenance.</a:t>
-            </a:r>
-          </a:p>
-          <a:p>
-            <a:endParaRPr lang="en-US" dirty="0"/>
-          </a:p>
-          <a:p>
-            <a:r>
-              <a:rPr lang="en-US" dirty="0"/>
-              <a:t>It is not necessary related to its size. But is related to how it was projected to assist the commuters.</a:t>
-            </a:r>
-          </a:p>
-          <a:p>
-            <a:endParaRPr lang="en-US" dirty="0"/>
-          </a:p>
-          <a:p>
-            <a:r>
-              <a:rPr lang="en-US" dirty="0"/>
-              <a:t>In a network without disruption, for instance, it would be a waste invest in redundancies. More money could be destinated to reduce travels time. </a:t>
-            </a:r>
-          </a:p>
-          <a:p>
-            <a:endParaRPr lang="en-US" dirty="0"/>
-          </a:p>
-          <a:p>
-            <a:r>
-              <a:rPr lang="en-US" dirty="0"/>
-              <a:t>In a real world, however, no disruptions comes with a high maintenance price. </a:t>
-            </a:r>
-          </a:p>
-          <a:p>
-            <a:endParaRPr lang="en-US" dirty="0"/>
-          </a:p>
-          <a:p>
-            <a:r>
-              <a:rPr lang="en-US" dirty="0"/>
-              <a:t>The balance between effectiveness and robustness is a major question when comes down to a such important factor of the society evolvement.</a:t>
-            </a:r>
-          </a:p>
-          <a:p>
-            <a:endParaRPr lang="en-US" dirty="0"/>
-          </a:p>
-          <a:p>
-            <a:endParaRPr lang="en-US" dirty="0"/>
-          </a:p>
-          <a:p>
-            <a:endParaRPr lang="en-US" dirty="0"/>
-          </a:p>
-          <a:p>
-            <a:endParaRPr lang="en-US" dirty="0"/>
-          </a:p>
-          <a:p>
-            <a:endParaRPr lang="en-US" dirty="0"/>
-          </a:p>
-          <a:p>
-            <a:endParaRPr lang="en-US" dirty="0"/>
+            <a:r>
+              <a:rPr lang="en-US" dirty="0">
+                <a:sym typeface="Wingdings" panose="05000000000000000000" pitchFamily="2" charset="2"/>
+              </a:rPr>
+              <a:t> Traffic</a:t>
+            </a:r>
+          </a:p>
+          <a:p>
+            <a:pPr marL="171450" indent="-171450">
+              <a:buFontTx/>
+              <a:buChar char="-"/>
+            </a:pPr>
+            <a:r>
+              <a:rPr lang="en-US" dirty="0">
+                <a:sym typeface="Wingdings" panose="05000000000000000000" pitchFamily="2" charset="2"/>
+              </a:rPr>
+              <a:t>Enter/Exists in stations (Networkx)</a:t>
+            </a:r>
+          </a:p>
+          <a:p>
+            <a:pPr marL="171450" indent="-171450">
+              <a:buFontTx/>
+              <a:buChar char="-"/>
+            </a:pPr>
+            <a:r>
+              <a:rPr lang="en-US" dirty="0">
+                <a:sym typeface="Wingdings" panose="05000000000000000000" pitchFamily="2" charset="2"/>
+              </a:rPr>
+              <a:t>Load in segments (Networkx)</a:t>
+            </a:r>
+          </a:p>
+          <a:p>
+            <a:pPr marL="171450" indent="-171450">
+              <a:buFontTx/>
+              <a:buChar char="-"/>
+            </a:pPr>
+            <a:endParaRPr lang="en-US" dirty="0">
+              <a:sym typeface="Wingdings" panose="05000000000000000000" pitchFamily="2" charset="2"/>
+            </a:endParaRPr>
+          </a:p>
+          <a:p>
+            <a:pPr marL="0" marR="0" lvl="0" indent="0" algn="l" defTabSz="914400" rtl="0" eaLnBrk="1" fontAlgn="auto" latinLnBrk="0" hangingPunct="1">
+              <a:lnSpc>
+                <a:spcPct val="100000"/>
+              </a:lnSpc>
+              <a:spcBef>
+                <a:spcPts val="0"/>
+              </a:spcBef>
+              <a:spcAft>
+                <a:spcPts val="0"/>
+              </a:spcAft>
+              <a:buClrTx/>
+              <a:buSzTx/>
+              <a:buFontTx/>
+              <a:buNone/>
+              <a:tabLst/>
+              <a:defRPr/>
+            </a:pPr>
+            <a:r>
+              <a:rPr lang="en-US" dirty="0">
+                <a:sym typeface="Wingdings" panose="05000000000000000000" pitchFamily="2" charset="2"/>
+              </a:rPr>
+              <a:t> User importance:</a:t>
+            </a:r>
+          </a:p>
+          <a:p>
+            <a:pPr marL="171450" indent="-171450">
+              <a:buFontTx/>
+              <a:buChar char="-"/>
+            </a:pPr>
+            <a:r>
+              <a:rPr lang="en-US" dirty="0">
+                <a:sym typeface="Wingdings" panose="05000000000000000000" pitchFamily="2" charset="2"/>
+              </a:rPr>
+              <a:t>Disparity ranking comparison</a:t>
+            </a:r>
+          </a:p>
+          <a:p>
+            <a:pPr marL="171450" indent="-171450">
+              <a:buFontTx/>
+              <a:buChar char="-"/>
+            </a:pPr>
+            <a:endParaRPr lang="en-US" dirty="0">
+              <a:sym typeface="Wingdings" panose="05000000000000000000" pitchFamily="2" charset="2"/>
+            </a:endParaRPr>
+          </a:p>
+          <a:p>
+            <a:pPr marL="0" marR="0" lvl="0" indent="0" algn="l" defTabSz="914400" rtl="0" eaLnBrk="1" fontAlgn="auto" latinLnBrk="0" hangingPunct="1">
+              <a:lnSpc>
+                <a:spcPct val="100000"/>
+              </a:lnSpc>
+              <a:spcBef>
+                <a:spcPts val="0"/>
+              </a:spcBef>
+              <a:spcAft>
+                <a:spcPts val="0"/>
+              </a:spcAft>
+              <a:buClrTx/>
+              <a:buSzTx/>
+              <a:buFontTx/>
+              <a:buNone/>
+              <a:tabLst/>
+              <a:defRPr/>
+            </a:pPr>
+            <a:r>
+              <a:rPr lang="en-US" dirty="0">
+                <a:sym typeface="Wingdings" panose="05000000000000000000" pitchFamily="2" charset="2"/>
+              </a:rPr>
+              <a:t> Collective importance:</a:t>
+            </a:r>
+          </a:p>
+          <a:p>
+            <a:pPr marL="171450" indent="-171450">
+              <a:buFontTx/>
+              <a:buChar char="-"/>
+            </a:pPr>
+            <a:r>
+              <a:rPr lang="en-US" dirty="0">
+                <a:sym typeface="Wingdings" panose="05000000000000000000" pitchFamily="2" charset="2"/>
+              </a:rPr>
+              <a:t>Distress ranking comparison</a:t>
+            </a:r>
           </a:p>
         </p:txBody>
       </p:sp>
@@ -4553,6 +4608,1023 @@
             <a:fld id="{3D19D2C4-D801-4083-8F60-14491AD78394}" type="slidenum">
               <a:rPr lang="fr-BE" smtClean="0"/>
               <a:t>23</a:t>
+            </a:fld>
+            <a:endParaRPr lang="fr-BE"/>
+          </a:p>
+        </p:txBody>
+      </p:sp>
+    </p:spTree>
+    <p:extLst>
+      <p:ext uri="{BB962C8B-B14F-4D97-AF65-F5344CB8AC3E}">
+        <p14:creationId xmlns:p14="http://schemas.microsoft.com/office/powerpoint/2010/main" val="2305896"/>
+      </p:ext>
+    </p:extLst>
+  </p:cSld>
+  <p:clrMapOvr>
+    <a:masterClrMapping/>
+  </p:clrMapOvr>
+</p:notes>
+</file>
+
+<file path=ppt/notesSlides/notesSlide23.xml><?xml version="1.0" encoding="utf-8"?>
+<p:notes xmlns:a="http://schemas.openxmlformats.org/drawingml/2006/main" xmlns:r="http://schemas.openxmlformats.org/officeDocument/2006/relationships" xmlns:p="http://schemas.openxmlformats.org/presentationml/2006/main">
+  <p:cSld>
+    <p:spTree>
+      <p:nvGrpSpPr>
+        <p:cNvPr id="1" name=""/>
+        <p:cNvGrpSpPr/>
+        <p:nvPr/>
+      </p:nvGrpSpPr>
+      <p:grpSpPr>
+        <a:xfrm>
+          <a:off x="0" y="0"/>
+          <a:ext cx="0" cy="0"/>
+          <a:chOff x="0" y="0"/>
+          <a:chExt cx="0" cy="0"/>
+        </a:xfrm>
+      </p:grpSpPr>
+      <p:sp>
+        <p:nvSpPr>
+          <p:cNvPr id="2" name="Slide Image Placeholder 1"/>
+          <p:cNvSpPr>
+            <a:spLocks noGrp="1" noRot="1" noChangeAspect="1"/>
+          </p:cNvSpPr>
+          <p:nvPr>
+            <p:ph type="sldImg"/>
+          </p:nvPr>
+        </p:nvSpPr>
+        <p:spPr/>
+      </p:sp>
+      <p:sp>
+        <p:nvSpPr>
+          <p:cNvPr id="3" name="Notes Placeholder 2"/>
+          <p:cNvSpPr>
+            <a:spLocks noGrp="1"/>
+          </p:cNvSpPr>
+          <p:nvPr>
+            <p:ph type="body" idx="1"/>
+          </p:nvPr>
+        </p:nvSpPr>
+        <p:spPr/>
+        <p:txBody>
+          <a:bodyPr/>
+          <a:lstStyle/>
+          <a:p>
+            <a:pPr marL="171450" indent="-171450">
+              <a:buFont typeface="Wingdings" panose="05000000000000000000" pitchFamily="2" charset="2"/>
+              <a:buChar char="à"/>
+            </a:pPr>
+            <a:r>
+              <a:rPr lang="en-US" dirty="0">
+                <a:sym typeface="Wingdings" panose="05000000000000000000" pitchFamily="2" charset="2"/>
+              </a:rPr>
+              <a:t>Operational: Speed &amp; Frequency</a:t>
+            </a:r>
+          </a:p>
+          <a:p>
+            <a:pPr marL="171450" indent="-171450">
+              <a:buFontTx/>
+              <a:buChar char="-"/>
+            </a:pPr>
+            <a:r>
+              <a:rPr lang="en-US" dirty="0">
+                <a:sym typeface="Wingdings" panose="05000000000000000000" pitchFamily="2" charset="2"/>
+              </a:rPr>
+              <a:t>Histogram (charts) weight</a:t>
+            </a:r>
+          </a:p>
+          <a:p>
+            <a:pPr marL="171450" indent="-171450">
+              <a:buFontTx/>
+              <a:buChar char="-"/>
+            </a:pPr>
+            <a:r>
+              <a:rPr lang="en-US" dirty="0">
+                <a:sym typeface="Wingdings" panose="05000000000000000000" pitchFamily="2" charset="2"/>
+              </a:rPr>
+              <a:t>Maps (Networkx)</a:t>
+            </a:r>
+          </a:p>
+          <a:p>
+            <a:pPr marL="0" indent="0">
+              <a:buFontTx/>
+              <a:buNone/>
+            </a:pPr>
+            <a:endParaRPr lang="en-US" dirty="0">
+              <a:sym typeface="Wingdings" panose="05000000000000000000" pitchFamily="2" charset="2"/>
+            </a:endParaRPr>
+          </a:p>
+          <a:p>
+            <a:pPr marL="0" marR="0" lvl="0" indent="0" algn="l" defTabSz="914400" rtl="0" eaLnBrk="1" fontAlgn="auto" latinLnBrk="0" hangingPunct="1">
+              <a:lnSpc>
+                <a:spcPct val="100000"/>
+              </a:lnSpc>
+              <a:spcBef>
+                <a:spcPts val="0"/>
+              </a:spcBef>
+              <a:spcAft>
+                <a:spcPts val="0"/>
+              </a:spcAft>
+              <a:buClrTx/>
+              <a:buSzTx/>
+              <a:buFontTx/>
+              <a:buNone/>
+              <a:tabLst/>
+              <a:defRPr/>
+            </a:pPr>
+            <a:r>
+              <a:rPr lang="en-US" dirty="0">
+                <a:sym typeface="Wingdings" panose="05000000000000000000" pitchFamily="2" charset="2"/>
+              </a:rPr>
+              <a:t> Traffic</a:t>
+            </a:r>
+          </a:p>
+          <a:p>
+            <a:pPr marL="171450" indent="-171450">
+              <a:buFontTx/>
+              <a:buChar char="-"/>
+            </a:pPr>
+            <a:r>
+              <a:rPr lang="en-US" dirty="0">
+                <a:sym typeface="Wingdings" panose="05000000000000000000" pitchFamily="2" charset="2"/>
+              </a:rPr>
+              <a:t>Enter/Exists in stations (Networkx)</a:t>
+            </a:r>
+          </a:p>
+          <a:p>
+            <a:pPr marL="171450" indent="-171450">
+              <a:buFontTx/>
+              <a:buChar char="-"/>
+            </a:pPr>
+            <a:r>
+              <a:rPr lang="en-US" dirty="0">
+                <a:sym typeface="Wingdings" panose="05000000000000000000" pitchFamily="2" charset="2"/>
+              </a:rPr>
+              <a:t>Load in segments (Networkx)</a:t>
+            </a:r>
+          </a:p>
+          <a:p>
+            <a:pPr marL="171450" indent="-171450">
+              <a:buFontTx/>
+              <a:buChar char="-"/>
+            </a:pPr>
+            <a:endParaRPr lang="en-US" dirty="0">
+              <a:sym typeface="Wingdings" panose="05000000000000000000" pitchFamily="2" charset="2"/>
+            </a:endParaRPr>
+          </a:p>
+          <a:p>
+            <a:pPr marL="0" marR="0" lvl="0" indent="0" algn="l" defTabSz="914400" rtl="0" eaLnBrk="1" fontAlgn="auto" latinLnBrk="0" hangingPunct="1">
+              <a:lnSpc>
+                <a:spcPct val="100000"/>
+              </a:lnSpc>
+              <a:spcBef>
+                <a:spcPts val="0"/>
+              </a:spcBef>
+              <a:spcAft>
+                <a:spcPts val="0"/>
+              </a:spcAft>
+              <a:buClrTx/>
+              <a:buSzTx/>
+              <a:buFontTx/>
+              <a:buNone/>
+              <a:tabLst/>
+              <a:defRPr/>
+            </a:pPr>
+            <a:r>
+              <a:rPr lang="en-US" dirty="0">
+                <a:sym typeface="Wingdings" panose="05000000000000000000" pitchFamily="2" charset="2"/>
+              </a:rPr>
+              <a:t> User importance:</a:t>
+            </a:r>
+          </a:p>
+          <a:p>
+            <a:pPr marL="171450" indent="-171450">
+              <a:buFontTx/>
+              <a:buChar char="-"/>
+            </a:pPr>
+            <a:r>
+              <a:rPr lang="en-US" dirty="0">
+                <a:sym typeface="Wingdings" panose="05000000000000000000" pitchFamily="2" charset="2"/>
+              </a:rPr>
+              <a:t>Disparity ranking comparison</a:t>
+            </a:r>
+          </a:p>
+          <a:p>
+            <a:pPr marL="171450" indent="-171450">
+              <a:buFontTx/>
+              <a:buChar char="-"/>
+            </a:pPr>
+            <a:endParaRPr lang="en-US" dirty="0">
+              <a:sym typeface="Wingdings" panose="05000000000000000000" pitchFamily="2" charset="2"/>
+            </a:endParaRPr>
+          </a:p>
+          <a:p>
+            <a:pPr marL="0" marR="0" lvl="0" indent="0" algn="l" defTabSz="914400" rtl="0" eaLnBrk="1" fontAlgn="auto" latinLnBrk="0" hangingPunct="1">
+              <a:lnSpc>
+                <a:spcPct val="100000"/>
+              </a:lnSpc>
+              <a:spcBef>
+                <a:spcPts val="0"/>
+              </a:spcBef>
+              <a:spcAft>
+                <a:spcPts val="0"/>
+              </a:spcAft>
+              <a:buClrTx/>
+              <a:buSzTx/>
+              <a:buFontTx/>
+              <a:buNone/>
+              <a:tabLst/>
+              <a:defRPr/>
+            </a:pPr>
+            <a:r>
+              <a:rPr lang="en-US" dirty="0">
+                <a:sym typeface="Wingdings" panose="05000000000000000000" pitchFamily="2" charset="2"/>
+              </a:rPr>
+              <a:t> Collective importance:</a:t>
+            </a:r>
+          </a:p>
+          <a:p>
+            <a:pPr marL="171450" indent="-171450">
+              <a:buFontTx/>
+              <a:buChar char="-"/>
+            </a:pPr>
+            <a:r>
+              <a:rPr lang="en-US" dirty="0">
+                <a:sym typeface="Wingdings" panose="05000000000000000000" pitchFamily="2" charset="2"/>
+              </a:rPr>
+              <a:t>Distress ranking comparison</a:t>
+            </a:r>
+          </a:p>
+        </p:txBody>
+      </p:sp>
+      <p:sp>
+        <p:nvSpPr>
+          <p:cNvPr id="4" name="Slide Number Placeholder 3"/>
+          <p:cNvSpPr>
+            <a:spLocks noGrp="1"/>
+          </p:cNvSpPr>
+          <p:nvPr>
+            <p:ph type="sldNum" sz="quarter" idx="5"/>
+          </p:nvPr>
+        </p:nvSpPr>
+        <p:spPr/>
+        <p:txBody>
+          <a:bodyPr/>
+          <a:lstStyle/>
+          <a:p>
+            <a:fld id="{3D19D2C4-D801-4083-8F60-14491AD78394}" type="slidenum">
+              <a:rPr lang="fr-BE" smtClean="0"/>
+              <a:t>24</a:t>
+            </a:fld>
+            <a:endParaRPr lang="fr-BE"/>
+          </a:p>
+        </p:txBody>
+      </p:sp>
+    </p:spTree>
+    <p:extLst>
+      <p:ext uri="{BB962C8B-B14F-4D97-AF65-F5344CB8AC3E}">
+        <p14:creationId xmlns:p14="http://schemas.microsoft.com/office/powerpoint/2010/main" val="3774980255"/>
+      </p:ext>
+    </p:extLst>
+  </p:cSld>
+  <p:clrMapOvr>
+    <a:masterClrMapping/>
+  </p:clrMapOvr>
+</p:notes>
+</file>
+
+<file path=ppt/notesSlides/notesSlide24.xml><?xml version="1.0" encoding="utf-8"?>
+<p:notes xmlns:a="http://schemas.openxmlformats.org/drawingml/2006/main" xmlns:r="http://schemas.openxmlformats.org/officeDocument/2006/relationships" xmlns:p="http://schemas.openxmlformats.org/presentationml/2006/main">
+  <p:cSld>
+    <p:spTree>
+      <p:nvGrpSpPr>
+        <p:cNvPr id="1" name=""/>
+        <p:cNvGrpSpPr/>
+        <p:nvPr/>
+      </p:nvGrpSpPr>
+      <p:grpSpPr>
+        <a:xfrm>
+          <a:off x="0" y="0"/>
+          <a:ext cx="0" cy="0"/>
+          <a:chOff x="0" y="0"/>
+          <a:chExt cx="0" cy="0"/>
+        </a:xfrm>
+      </p:grpSpPr>
+      <p:sp>
+        <p:nvSpPr>
+          <p:cNvPr id="2" name="Slide Image Placeholder 1"/>
+          <p:cNvSpPr>
+            <a:spLocks noGrp="1" noRot="1" noChangeAspect="1"/>
+          </p:cNvSpPr>
+          <p:nvPr>
+            <p:ph type="sldImg"/>
+          </p:nvPr>
+        </p:nvSpPr>
+        <p:spPr/>
+      </p:sp>
+      <p:sp>
+        <p:nvSpPr>
+          <p:cNvPr id="3" name="Notes Placeholder 2"/>
+          <p:cNvSpPr>
+            <a:spLocks noGrp="1"/>
+          </p:cNvSpPr>
+          <p:nvPr>
+            <p:ph type="body" idx="1"/>
+          </p:nvPr>
+        </p:nvSpPr>
+        <p:spPr/>
+        <p:txBody>
+          <a:bodyPr/>
+          <a:lstStyle/>
+          <a:p>
+            <a:pPr marL="171450" indent="-171450">
+              <a:buFont typeface="Wingdings" panose="05000000000000000000" pitchFamily="2" charset="2"/>
+              <a:buChar char="à"/>
+            </a:pPr>
+            <a:r>
+              <a:rPr lang="en-US" dirty="0">
+                <a:sym typeface="Wingdings" panose="05000000000000000000" pitchFamily="2" charset="2"/>
+              </a:rPr>
+              <a:t>Operational: Speed &amp; Frequency</a:t>
+            </a:r>
+          </a:p>
+          <a:p>
+            <a:pPr marL="171450" indent="-171450">
+              <a:buFontTx/>
+              <a:buChar char="-"/>
+            </a:pPr>
+            <a:r>
+              <a:rPr lang="en-US" dirty="0">
+                <a:sym typeface="Wingdings" panose="05000000000000000000" pitchFamily="2" charset="2"/>
+              </a:rPr>
+              <a:t>Histogram (charts) weight</a:t>
+            </a:r>
+          </a:p>
+          <a:p>
+            <a:pPr marL="171450" indent="-171450">
+              <a:buFontTx/>
+              <a:buChar char="-"/>
+            </a:pPr>
+            <a:r>
+              <a:rPr lang="en-US" dirty="0">
+                <a:sym typeface="Wingdings" panose="05000000000000000000" pitchFamily="2" charset="2"/>
+              </a:rPr>
+              <a:t>Maps (Networkx)</a:t>
+            </a:r>
+          </a:p>
+          <a:p>
+            <a:pPr marL="0" indent="0">
+              <a:buFontTx/>
+              <a:buNone/>
+            </a:pPr>
+            <a:endParaRPr lang="en-US" dirty="0">
+              <a:sym typeface="Wingdings" panose="05000000000000000000" pitchFamily="2" charset="2"/>
+            </a:endParaRPr>
+          </a:p>
+          <a:p>
+            <a:pPr marL="0" marR="0" lvl="0" indent="0" algn="l" defTabSz="914400" rtl="0" eaLnBrk="1" fontAlgn="auto" latinLnBrk="0" hangingPunct="1">
+              <a:lnSpc>
+                <a:spcPct val="100000"/>
+              </a:lnSpc>
+              <a:spcBef>
+                <a:spcPts val="0"/>
+              </a:spcBef>
+              <a:spcAft>
+                <a:spcPts val="0"/>
+              </a:spcAft>
+              <a:buClrTx/>
+              <a:buSzTx/>
+              <a:buFontTx/>
+              <a:buNone/>
+              <a:tabLst/>
+              <a:defRPr/>
+            </a:pPr>
+            <a:r>
+              <a:rPr lang="en-US" dirty="0">
+                <a:sym typeface="Wingdings" panose="05000000000000000000" pitchFamily="2" charset="2"/>
+              </a:rPr>
+              <a:t> Traffic</a:t>
+            </a:r>
+          </a:p>
+          <a:p>
+            <a:pPr marL="171450" indent="-171450">
+              <a:buFontTx/>
+              <a:buChar char="-"/>
+            </a:pPr>
+            <a:r>
+              <a:rPr lang="en-US" dirty="0">
+                <a:sym typeface="Wingdings" panose="05000000000000000000" pitchFamily="2" charset="2"/>
+              </a:rPr>
+              <a:t>Enter/Exists in stations (Networkx)</a:t>
+            </a:r>
+          </a:p>
+          <a:p>
+            <a:pPr marL="171450" indent="-171450">
+              <a:buFontTx/>
+              <a:buChar char="-"/>
+            </a:pPr>
+            <a:r>
+              <a:rPr lang="en-US" dirty="0">
+                <a:sym typeface="Wingdings" panose="05000000000000000000" pitchFamily="2" charset="2"/>
+              </a:rPr>
+              <a:t>Load in segments (Networkx)</a:t>
+            </a:r>
+          </a:p>
+          <a:p>
+            <a:pPr marL="171450" indent="-171450">
+              <a:buFontTx/>
+              <a:buChar char="-"/>
+            </a:pPr>
+            <a:endParaRPr lang="en-US" dirty="0">
+              <a:sym typeface="Wingdings" panose="05000000000000000000" pitchFamily="2" charset="2"/>
+            </a:endParaRPr>
+          </a:p>
+          <a:p>
+            <a:pPr marL="0" marR="0" lvl="0" indent="0" algn="l" defTabSz="914400" rtl="0" eaLnBrk="1" fontAlgn="auto" latinLnBrk="0" hangingPunct="1">
+              <a:lnSpc>
+                <a:spcPct val="100000"/>
+              </a:lnSpc>
+              <a:spcBef>
+                <a:spcPts val="0"/>
+              </a:spcBef>
+              <a:spcAft>
+                <a:spcPts val="0"/>
+              </a:spcAft>
+              <a:buClrTx/>
+              <a:buSzTx/>
+              <a:buFontTx/>
+              <a:buNone/>
+              <a:tabLst/>
+              <a:defRPr/>
+            </a:pPr>
+            <a:r>
+              <a:rPr lang="en-US" dirty="0">
+                <a:sym typeface="Wingdings" panose="05000000000000000000" pitchFamily="2" charset="2"/>
+              </a:rPr>
+              <a:t> User importance:</a:t>
+            </a:r>
+          </a:p>
+          <a:p>
+            <a:pPr marL="171450" indent="-171450">
+              <a:buFontTx/>
+              <a:buChar char="-"/>
+            </a:pPr>
+            <a:r>
+              <a:rPr lang="en-US" dirty="0">
+                <a:sym typeface="Wingdings" panose="05000000000000000000" pitchFamily="2" charset="2"/>
+              </a:rPr>
+              <a:t>Disparity ranking comparison</a:t>
+            </a:r>
+          </a:p>
+          <a:p>
+            <a:pPr marL="171450" indent="-171450">
+              <a:buFontTx/>
+              <a:buChar char="-"/>
+            </a:pPr>
+            <a:endParaRPr lang="en-US" dirty="0">
+              <a:sym typeface="Wingdings" panose="05000000000000000000" pitchFamily="2" charset="2"/>
+            </a:endParaRPr>
+          </a:p>
+          <a:p>
+            <a:pPr marL="0" marR="0" lvl="0" indent="0" algn="l" defTabSz="914400" rtl="0" eaLnBrk="1" fontAlgn="auto" latinLnBrk="0" hangingPunct="1">
+              <a:lnSpc>
+                <a:spcPct val="100000"/>
+              </a:lnSpc>
+              <a:spcBef>
+                <a:spcPts val="0"/>
+              </a:spcBef>
+              <a:spcAft>
+                <a:spcPts val="0"/>
+              </a:spcAft>
+              <a:buClrTx/>
+              <a:buSzTx/>
+              <a:buFontTx/>
+              <a:buNone/>
+              <a:tabLst/>
+              <a:defRPr/>
+            </a:pPr>
+            <a:r>
+              <a:rPr lang="en-US" dirty="0">
+                <a:sym typeface="Wingdings" panose="05000000000000000000" pitchFamily="2" charset="2"/>
+              </a:rPr>
+              <a:t> Collective importance:</a:t>
+            </a:r>
+          </a:p>
+          <a:p>
+            <a:pPr marL="171450" indent="-171450">
+              <a:buFontTx/>
+              <a:buChar char="-"/>
+            </a:pPr>
+            <a:r>
+              <a:rPr lang="en-US" dirty="0">
+                <a:sym typeface="Wingdings" panose="05000000000000000000" pitchFamily="2" charset="2"/>
+              </a:rPr>
+              <a:t>Distress ranking comparison</a:t>
+            </a:r>
+          </a:p>
+        </p:txBody>
+      </p:sp>
+      <p:sp>
+        <p:nvSpPr>
+          <p:cNvPr id="4" name="Slide Number Placeholder 3"/>
+          <p:cNvSpPr>
+            <a:spLocks noGrp="1"/>
+          </p:cNvSpPr>
+          <p:nvPr>
+            <p:ph type="sldNum" sz="quarter" idx="5"/>
+          </p:nvPr>
+        </p:nvSpPr>
+        <p:spPr/>
+        <p:txBody>
+          <a:bodyPr/>
+          <a:lstStyle/>
+          <a:p>
+            <a:fld id="{3D19D2C4-D801-4083-8F60-14491AD78394}" type="slidenum">
+              <a:rPr lang="fr-BE" smtClean="0"/>
+              <a:t>25</a:t>
+            </a:fld>
+            <a:endParaRPr lang="fr-BE"/>
+          </a:p>
+        </p:txBody>
+      </p:sp>
+    </p:spTree>
+    <p:extLst>
+      <p:ext uri="{BB962C8B-B14F-4D97-AF65-F5344CB8AC3E}">
+        <p14:creationId xmlns:p14="http://schemas.microsoft.com/office/powerpoint/2010/main" val="203907506"/>
+      </p:ext>
+    </p:extLst>
+  </p:cSld>
+  <p:clrMapOvr>
+    <a:masterClrMapping/>
+  </p:clrMapOvr>
+</p:notes>
+</file>
+
+<file path=ppt/notesSlides/notesSlide25.xml><?xml version="1.0" encoding="utf-8"?>
+<p:notes xmlns:a="http://schemas.openxmlformats.org/drawingml/2006/main" xmlns:r="http://schemas.openxmlformats.org/officeDocument/2006/relationships" xmlns:p="http://schemas.openxmlformats.org/presentationml/2006/main">
+  <p:cSld>
+    <p:spTree>
+      <p:nvGrpSpPr>
+        <p:cNvPr id="1" name=""/>
+        <p:cNvGrpSpPr/>
+        <p:nvPr/>
+      </p:nvGrpSpPr>
+      <p:grpSpPr>
+        <a:xfrm>
+          <a:off x="0" y="0"/>
+          <a:ext cx="0" cy="0"/>
+          <a:chOff x="0" y="0"/>
+          <a:chExt cx="0" cy="0"/>
+        </a:xfrm>
+      </p:grpSpPr>
+      <p:sp>
+        <p:nvSpPr>
+          <p:cNvPr id="2" name="Slide Image Placeholder 1"/>
+          <p:cNvSpPr>
+            <a:spLocks noGrp="1" noRot="1" noChangeAspect="1"/>
+          </p:cNvSpPr>
+          <p:nvPr>
+            <p:ph type="sldImg"/>
+          </p:nvPr>
+        </p:nvSpPr>
+        <p:spPr/>
+      </p:sp>
+      <p:sp>
+        <p:nvSpPr>
+          <p:cNvPr id="3" name="Notes Placeholder 2"/>
+          <p:cNvSpPr>
+            <a:spLocks noGrp="1"/>
+          </p:cNvSpPr>
+          <p:nvPr>
+            <p:ph type="body" idx="1"/>
+          </p:nvPr>
+        </p:nvSpPr>
+        <p:spPr/>
+        <p:txBody>
+          <a:bodyPr/>
+          <a:lstStyle/>
+          <a:p>
+            <a:pPr marL="0" indent="0">
+              <a:buNone/>
+            </a:pPr>
+            <a:endParaRPr lang="en-US" dirty="0"/>
+          </a:p>
+          <a:p>
+            <a:pPr marL="0" marR="0" lvl="0" indent="0" algn="l" defTabSz="914400" rtl="0" eaLnBrk="1" fontAlgn="auto" latinLnBrk="0" hangingPunct="1">
+              <a:lnSpc>
+                <a:spcPct val="100000"/>
+              </a:lnSpc>
+              <a:spcBef>
+                <a:spcPts val="0"/>
+              </a:spcBef>
+              <a:spcAft>
+                <a:spcPts val="0"/>
+              </a:spcAft>
+              <a:buClrTx/>
+              <a:buSzTx/>
+              <a:buFontTx/>
+              <a:buNone/>
+              <a:tabLst/>
+              <a:defRPr/>
+            </a:pPr>
+            <a:r>
+              <a:rPr lang="en-US" dirty="0"/>
+              <a:t>1) </a:t>
+            </a:r>
+            <a:r>
+              <a:rPr lang="en-US" dirty="0">
+                <a:sym typeface="Wingdings" panose="05000000000000000000" pitchFamily="2" charset="2"/>
+              </a:rPr>
+              <a:t>Interconnect all possible modes of transport including bikes and walks.</a:t>
+            </a:r>
+            <a:endParaRPr lang="en-US" dirty="0"/>
+          </a:p>
+          <a:p>
+            <a:pPr marL="0" indent="0">
+              <a:buNone/>
+            </a:pPr>
+            <a:endParaRPr lang="en-US" dirty="0"/>
+          </a:p>
+          <a:p>
+            <a:pPr marL="0" indent="0">
+              <a:buNone/>
+            </a:pPr>
+            <a:endParaRPr lang="en-US" dirty="0"/>
+          </a:p>
+          <a:p>
+            <a:pPr marL="0" indent="0">
+              <a:buNone/>
+            </a:pPr>
+            <a:r>
+              <a:rPr lang="en-US" dirty="0"/>
+              <a:t>2) Use ML models for predictions of:</a:t>
+            </a:r>
+          </a:p>
+          <a:p>
+            <a:pPr marL="228600" indent="-228600">
+              <a:buAutoNum type="arabicParenR"/>
+            </a:pPr>
+            <a:endParaRPr lang="en-US" dirty="0"/>
+          </a:p>
+          <a:p>
+            <a:pPr marL="171450" indent="-171450">
+              <a:buFont typeface="Wingdings" panose="05000000000000000000" pitchFamily="2" charset="2"/>
+              <a:buChar char="à"/>
+            </a:pPr>
+            <a:r>
+              <a:rPr lang="en-US" dirty="0"/>
+              <a:t>TRAFFIC: Passenger flow: </a:t>
+            </a:r>
+            <a:r>
+              <a:rPr lang="en-US" b="0" i="0" dirty="0">
+                <a:solidFill>
+                  <a:srgbClr val="24292F"/>
+                </a:solidFill>
+                <a:effectLst/>
+                <a:latin typeface="-apple-system"/>
+              </a:rPr>
+              <a:t>From network lens (keeping passenger anonymity) , use more data (daily events) to more accurately understand why traffic is generated in each segments;</a:t>
+            </a:r>
+          </a:p>
+          <a:p>
+            <a:pPr marL="171450" indent="-171450">
+              <a:buFont typeface="Wingdings" panose="05000000000000000000" pitchFamily="2" charset="2"/>
+              <a:buChar char="à"/>
+            </a:pPr>
+            <a:endParaRPr lang="en-US" b="0" i="0" dirty="0">
+              <a:solidFill>
+                <a:srgbClr val="24292F"/>
+              </a:solidFill>
+              <a:effectLst/>
+              <a:latin typeface="-apple-system"/>
+            </a:endParaRPr>
+          </a:p>
+          <a:p>
+            <a:pPr marL="171450" indent="-171450">
+              <a:buFont typeface="Wingdings" panose="05000000000000000000" pitchFamily="2" charset="2"/>
+              <a:buChar char="à"/>
+            </a:pPr>
+            <a:r>
+              <a:rPr lang="en-US" b="0" i="0" dirty="0">
+                <a:solidFill>
+                  <a:srgbClr val="24292F"/>
+                </a:solidFill>
+                <a:effectLst/>
+                <a:latin typeface="-apple-system"/>
+              </a:rPr>
+              <a:t>OPEX: Predict disruptions and its impact considering forecasted passenger traffic to optimize maintenance planning.</a:t>
+            </a:r>
+          </a:p>
+          <a:p>
+            <a:pPr marL="171450" indent="-171450">
+              <a:buFont typeface="Wingdings" panose="05000000000000000000" pitchFamily="2" charset="2"/>
+              <a:buChar char="à"/>
+            </a:pPr>
+            <a:endParaRPr lang="en-US" b="0" i="0" dirty="0">
+              <a:solidFill>
+                <a:srgbClr val="24292F"/>
+              </a:solidFill>
+              <a:effectLst/>
+              <a:latin typeface="-apple-system"/>
+            </a:endParaRPr>
+          </a:p>
+          <a:p>
+            <a:pPr marL="171450" marR="0" lvl="0" indent="-171450" algn="l" defTabSz="914400" rtl="0" eaLnBrk="1" fontAlgn="auto" latinLnBrk="0" hangingPunct="1">
+              <a:lnSpc>
+                <a:spcPct val="100000"/>
+              </a:lnSpc>
+              <a:spcBef>
+                <a:spcPts val="0"/>
+              </a:spcBef>
+              <a:spcAft>
+                <a:spcPts val="0"/>
+              </a:spcAft>
+              <a:buClrTx/>
+              <a:buSzTx/>
+              <a:buFont typeface="Wingdings" panose="05000000000000000000" pitchFamily="2" charset="2"/>
+              <a:buChar char="à"/>
+              <a:tabLst/>
+              <a:defRPr/>
+            </a:pPr>
+            <a:r>
+              <a:rPr lang="en-US" b="0" i="0" dirty="0">
+                <a:solidFill>
+                  <a:srgbClr val="24292F"/>
+                </a:solidFill>
+                <a:effectLst/>
+                <a:latin typeface="-apple-system"/>
+              </a:rPr>
+              <a:t>Create a timetable dynamically tailored that optimize infra-structure towards the commuters needs.</a:t>
+            </a:r>
+          </a:p>
+          <a:p>
+            <a:pPr marL="171450" indent="-171450">
+              <a:buFont typeface="Wingdings" panose="05000000000000000000" pitchFamily="2" charset="2"/>
+              <a:buChar char="à"/>
+            </a:pPr>
+            <a:endParaRPr lang="en-US" b="0" i="0" dirty="0">
+              <a:solidFill>
+                <a:srgbClr val="24292F"/>
+              </a:solidFill>
+              <a:effectLst/>
+              <a:latin typeface="-apple-system"/>
+            </a:endParaRPr>
+          </a:p>
+          <a:p>
+            <a:pPr marL="171450" indent="-171450">
+              <a:buFont typeface="Wingdings" panose="05000000000000000000" pitchFamily="2" charset="2"/>
+              <a:buChar char="à"/>
+            </a:pPr>
+            <a:r>
+              <a:rPr lang="en-US" b="0" i="0" dirty="0">
+                <a:solidFill>
+                  <a:srgbClr val="24292F"/>
+                </a:solidFill>
+                <a:effectLst/>
+                <a:latin typeface="-apple-system"/>
+              </a:rPr>
+              <a:t>CAPEX: More maintenance, less disruptions, less need for redundancy and more investment express lanes (study of origin and destination). </a:t>
+            </a:r>
+          </a:p>
+          <a:p>
+            <a:pPr marL="171450" indent="-171450">
+              <a:buFont typeface="Wingdings" panose="05000000000000000000" pitchFamily="2" charset="2"/>
+              <a:buChar char="à"/>
+            </a:pPr>
+            <a:endParaRPr lang="en-US" b="0" i="0" dirty="0">
+              <a:solidFill>
+                <a:srgbClr val="24292F"/>
+              </a:solidFill>
+              <a:effectLst/>
+              <a:latin typeface="-apple-system"/>
+            </a:endParaRPr>
+          </a:p>
+          <a:p>
+            <a:pPr marL="171450" indent="-171450">
+              <a:buFont typeface="Wingdings" panose="05000000000000000000" pitchFamily="2" charset="2"/>
+              <a:buChar char="à"/>
+            </a:pPr>
+            <a:endParaRPr lang="en-US" b="0" i="0" dirty="0">
+              <a:solidFill>
+                <a:srgbClr val="24292F"/>
+              </a:solidFill>
+              <a:effectLst/>
+              <a:latin typeface="-apple-system"/>
+            </a:endParaRPr>
+          </a:p>
+          <a:p>
+            <a:pPr marL="0" indent="0">
+              <a:buFont typeface="Wingdings" panose="05000000000000000000" pitchFamily="2" charset="2"/>
+              <a:buNone/>
+            </a:pPr>
+            <a:endParaRPr lang="en-US" b="0" i="0" dirty="0">
+              <a:solidFill>
+                <a:srgbClr val="24292F"/>
+              </a:solidFill>
+              <a:effectLst/>
+              <a:latin typeface="-apple-system"/>
+            </a:endParaRPr>
+          </a:p>
+          <a:p>
+            <a:pPr marL="171450" indent="-171450">
+              <a:buFont typeface="Wingdings" panose="05000000000000000000" pitchFamily="2" charset="2"/>
+              <a:buChar char="à"/>
+            </a:pPr>
+            <a:endParaRPr lang="en-US" b="0" i="0" dirty="0">
+              <a:solidFill>
+                <a:srgbClr val="24292F"/>
+              </a:solidFill>
+              <a:effectLst/>
+              <a:latin typeface="-apple-system"/>
+            </a:endParaRPr>
+          </a:p>
+        </p:txBody>
+      </p:sp>
+      <p:sp>
+        <p:nvSpPr>
+          <p:cNvPr id="4" name="Slide Number Placeholder 3"/>
+          <p:cNvSpPr>
+            <a:spLocks noGrp="1"/>
+          </p:cNvSpPr>
+          <p:nvPr>
+            <p:ph type="sldNum" sz="quarter" idx="5"/>
+          </p:nvPr>
+        </p:nvSpPr>
+        <p:spPr/>
+        <p:txBody>
+          <a:bodyPr/>
+          <a:lstStyle/>
+          <a:p>
+            <a:fld id="{3D19D2C4-D801-4083-8F60-14491AD78394}" type="slidenum">
+              <a:rPr lang="fr-BE" smtClean="0"/>
+              <a:t>26</a:t>
+            </a:fld>
+            <a:endParaRPr lang="fr-BE"/>
+          </a:p>
+        </p:txBody>
+      </p:sp>
+    </p:spTree>
+    <p:extLst>
+      <p:ext uri="{BB962C8B-B14F-4D97-AF65-F5344CB8AC3E}">
+        <p14:creationId xmlns:p14="http://schemas.microsoft.com/office/powerpoint/2010/main" val="2618829657"/>
+      </p:ext>
+    </p:extLst>
+  </p:cSld>
+  <p:clrMapOvr>
+    <a:masterClrMapping/>
+  </p:clrMapOvr>
+</p:notes>
+</file>
+
+<file path=ppt/notesSlides/notesSlide26.xml><?xml version="1.0" encoding="utf-8"?>
+<p:notes xmlns:a="http://schemas.openxmlformats.org/drawingml/2006/main" xmlns:r="http://schemas.openxmlformats.org/officeDocument/2006/relationships" xmlns:p="http://schemas.openxmlformats.org/presentationml/2006/main">
+  <p:cSld>
+    <p:spTree>
+      <p:nvGrpSpPr>
+        <p:cNvPr id="1" name=""/>
+        <p:cNvGrpSpPr/>
+        <p:nvPr/>
+      </p:nvGrpSpPr>
+      <p:grpSpPr>
+        <a:xfrm>
+          <a:off x="0" y="0"/>
+          <a:ext cx="0" cy="0"/>
+          <a:chOff x="0" y="0"/>
+          <a:chExt cx="0" cy="0"/>
+        </a:xfrm>
+      </p:grpSpPr>
+      <p:sp>
+        <p:nvSpPr>
+          <p:cNvPr id="2" name="Slide Image Placeholder 1"/>
+          <p:cNvSpPr>
+            <a:spLocks noGrp="1" noRot="1" noChangeAspect="1"/>
+          </p:cNvSpPr>
+          <p:nvPr>
+            <p:ph type="sldImg"/>
+          </p:nvPr>
+        </p:nvSpPr>
+        <p:spPr/>
+      </p:sp>
+      <p:sp>
+        <p:nvSpPr>
+          <p:cNvPr id="3" name="Notes Placeholder 2"/>
+          <p:cNvSpPr>
+            <a:spLocks noGrp="1"/>
+          </p:cNvSpPr>
+          <p:nvPr>
+            <p:ph type="body" idx="1"/>
+          </p:nvPr>
+        </p:nvSpPr>
+        <p:spPr/>
+        <p:txBody>
+          <a:bodyPr/>
+          <a:lstStyle/>
+          <a:p>
+            <a:r>
+              <a:rPr lang="en-US" dirty="0"/>
+              <a:t>What is a efficient network = minimizes travel time and costs (vehicles, energy, emissions, price) assuring passenger “comfort” and “prompt mobility”.</a:t>
+            </a:r>
+          </a:p>
+          <a:p>
+            <a:pPr marL="0" marR="0" lvl="0" indent="0" algn="l" defTabSz="914400" rtl="0" eaLnBrk="1" fontAlgn="auto" latinLnBrk="0" hangingPunct="1">
+              <a:lnSpc>
+                <a:spcPct val="100000"/>
+              </a:lnSpc>
+              <a:spcBef>
+                <a:spcPts val="0"/>
+              </a:spcBef>
+              <a:spcAft>
+                <a:spcPts val="0"/>
+              </a:spcAft>
+              <a:buClrTx/>
+              <a:buSzTx/>
+              <a:buFontTx/>
+              <a:buNone/>
+              <a:tabLst/>
+              <a:defRPr/>
+            </a:pPr>
+            <a:endParaRPr lang="en-US" dirty="0"/>
+          </a:p>
+          <a:p>
+            <a:r>
+              <a:rPr lang="en-US" dirty="0"/>
+              <a:t>It is important to mention that a more efficient network inherently requires more maintenance.</a:t>
+            </a:r>
+          </a:p>
+          <a:p>
+            <a:endParaRPr lang="en-US" dirty="0"/>
+          </a:p>
+          <a:p>
+            <a:r>
+              <a:rPr lang="en-US" dirty="0"/>
+              <a:t>It is not necessary related to its size. But is related to how it was projected to assist the commuters.</a:t>
+            </a:r>
+          </a:p>
+          <a:p>
+            <a:endParaRPr lang="en-US" dirty="0"/>
+          </a:p>
+          <a:p>
+            <a:r>
+              <a:rPr lang="en-US" dirty="0"/>
+              <a:t>In a network without disruption, for instance, it would be a waste invest in redundancies. More money could be destinated to reduce travels time. </a:t>
+            </a:r>
+          </a:p>
+          <a:p>
+            <a:endParaRPr lang="en-US" dirty="0"/>
+          </a:p>
+          <a:p>
+            <a:r>
+              <a:rPr lang="en-US" dirty="0"/>
+              <a:t>In a real world, however, no disruptions comes with a high maintenance price. </a:t>
+            </a:r>
+          </a:p>
+          <a:p>
+            <a:endParaRPr lang="en-US" dirty="0"/>
+          </a:p>
+          <a:p>
+            <a:r>
+              <a:rPr lang="en-US" dirty="0"/>
+              <a:t>The balance between effectiveness and robustness is a major question when comes down to a such important factor of the society evolvement.</a:t>
+            </a:r>
+          </a:p>
+          <a:p>
+            <a:endParaRPr lang="en-US" dirty="0"/>
+          </a:p>
+          <a:p>
+            <a:endParaRPr lang="en-US" dirty="0"/>
+          </a:p>
+          <a:p>
+            <a:endParaRPr lang="en-US" dirty="0"/>
+          </a:p>
+          <a:p>
+            <a:endParaRPr lang="en-US" dirty="0"/>
+          </a:p>
+          <a:p>
+            <a:endParaRPr lang="en-US" dirty="0"/>
+          </a:p>
+          <a:p>
+            <a:endParaRPr lang="en-US" dirty="0"/>
+          </a:p>
+        </p:txBody>
+      </p:sp>
+      <p:sp>
+        <p:nvSpPr>
+          <p:cNvPr id="4" name="Slide Number Placeholder 3"/>
+          <p:cNvSpPr>
+            <a:spLocks noGrp="1"/>
+          </p:cNvSpPr>
+          <p:nvPr>
+            <p:ph type="sldNum" sz="quarter" idx="5"/>
+          </p:nvPr>
+        </p:nvSpPr>
+        <p:spPr/>
+        <p:txBody>
+          <a:bodyPr/>
+          <a:lstStyle/>
+          <a:p>
+            <a:fld id="{3D19D2C4-D801-4083-8F60-14491AD78394}" type="slidenum">
+              <a:rPr lang="fr-BE" smtClean="0"/>
+              <a:t>27</a:t>
             </a:fld>
             <a:endParaRPr lang="fr-BE"/>
           </a:p>
@@ -5622,7 +6694,7 @@
           <a:p>
             <a:fld id="{CCC07DD4-E8D6-4581-B1F4-04F48CF9E11E}" type="datetimeFigureOut">
               <a:rPr lang="fr-BE" smtClean="0"/>
-              <a:t>10-10-23</a:t>
+              <a:t>29-10-23</a:t>
             </a:fld>
             <a:endParaRPr lang="fr-BE"/>
           </a:p>
@@ -5822,7 +6894,7 @@
           <a:p>
             <a:fld id="{CCC07DD4-E8D6-4581-B1F4-04F48CF9E11E}" type="datetimeFigureOut">
               <a:rPr lang="fr-BE" smtClean="0"/>
-              <a:t>10-10-23</a:t>
+              <a:t>29-10-23</a:t>
             </a:fld>
             <a:endParaRPr lang="fr-BE"/>
           </a:p>
@@ -6032,7 +7104,7 @@
           <a:p>
             <a:fld id="{CCC07DD4-E8D6-4581-B1F4-04F48CF9E11E}" type="datetimeFigureOut">
               <a:rPr lang="fr-BE" smtClean="0"/>
-              <a:t>10-10-23</a:t>
+              <a:t>29-10-23</a:t>
             </a:fld>
             <a:endParaRPr lang="fr-BE"/>
           </a:p>
@@ -6232,7 +7304,7 @@
           <a:p>
             <a:fld id="{CCC07DD4-E8D6-4581-B1F4-04F48CF9E11E}" type="datetimeFigureOut">
               <a:rPr lang="fr-BE" smtClean="0"/>
-              <a:t>10-10-23</a:t>
+              <a:t>29-10-23</a:t>
             </a:fld>
             <a:endParaRPr lang="fr-BE"/>
           </a:p>
@@ -6508,7 +7580,7 @@
           <a:p>
             <a:fld id="{CCC07DD4-E8D6-4581-B1F4-04F48CF9E11E}" type="datetimeFigureOut">
               <a:rPr lang="fr-BE" smtClean="0"/>
-              <a:t>10-10-23</a:t>
+              <a:t>29-10-23</a:t>
             </a:fld>
             <a:endParaRPr lang="fr-BE"/>
           </a:p>
@@ -6776,7 +7848,7 @@
           <a:p>
             <a:fld id="{CCC07DD4-E8D6-4581-B1F4-04F48CF9E11E}" type="datetimeFigureOut">
               <a:rPr lang="fr-BE" smtClean="0"/>
-              <a:t>10-10-23</a:t>
+              <a:t>29-10-23</a:t>
             </a:fld>
             <a:endParaRPr lang="fr-BE"/>
           </a:p>
@@ -7191,7 +8263,7 @@
           <a:p>
             <a:fld id="{CCC07DD4-E8D6-4581-B1F4-04F48CF9E11E}" type="datetimeFigureOut">
               <a:rPr lang="fr-BE" smtClean="0"/>
-              <a:t>10-10-23</a:t>
+              <a:t>29-10-23</a:t>
             </a:fld>
             <a:endParaRPr lang="fr-BE"/>
           </a:p>
@@ -7333,7 +8405,7 @@
           <a:p>
             <a:fld id="{CCC07DD4-E8D6-4581-B1F4-04F48CF9E11E}" type="datetimeFigureOut">
               <a:rPr lang="fr-BE" smtClean="0"/>
-              <a:t>10-10-23</a:t>
+              <a:t>29-10-23</a:t>
             </a:fld>
             <a:endParaRPr lang="fr-BE"/>
           </a:p>
@@ -7446,7 +8518,7 @@
           <a:p>
             <a:fld id="{CCC07DD4-E8D6-4581-B1F4-04F48CF9E11E}" type="datetimeFigureOut">
               <a:rPr lang="fr-BE" smtClean="0"/>
-              <a:t>10-10-23</a:t>
+              <a:t>29-10-23</a:t>
             </a:fld>
             <a:endParaRPr lang="fr-BE"/>
           </a:p>
@@ -7759,7 +8831,7 @@
           <a:p>
             <a:fld id="{CCC07DD4-E8D6-4581-B1F4-04F48CF9E11E}" type="datetimeFigureOut">
               <a:rPr lang="fr-BE" smtClean="0"/>
-              <a:t>10-10-23</a:t>
+              <a:t>29-10-23</a:t>
             </a:fld>
             <a:endParaRPr lang="fr-BE"/>
           </a:p>
@@ -8048,7 +9120,7 @@
           <a:p>
             <a:fld id="{CCC07DD4-E8D6-4581-B1F4-04F48CF9E11E}" type="datetimeFigureOut">
               <a:rPr lang="fr-BE" smtClean="0"/>
-              <a:t>10-10-23</a:t>
+              <a:t>29-10-23</a:t>
             </a:fld>
             <a:endParaRPr lang="fr-BE"/>
           </a:p>
@@ -8291,7 +9363,7 @@
           <a:p>
             <a:fld id="{CCC07DD4-E8D6-4581-B1F4-04F48CF9E11E}" type="datetimeFigureOut">
               <a:rPr lang="fr-BE" smtClean="0"/>
-              <a:t>10-10-23</a:t>
+              <a:t>29-10-23</a:t>
             </a:fld>
             <a:endParaRPr lang="fr-BE"/>
           </a:p>
@@ -11698,8 +12770,8 @@
           </a:p>
         </p:txBody>
       </p:sp>
-      <mc:AlternateContent xmlns:mc="http://schemas.openxmlformats.org/markup-compatibility/2006">
-        <mc:Choice xmlns:a14="http://schemas.microsoft.com/office/drawing/2010/main" Requires="a14">
+      <mc:AlternateContent xmlns:mc="http://schemas.openxmlformats.org/markup-compatibility/2006" xmlns:a14="http://schemas.microsoft.com/office/drawing/2010/main">
+        <mc:Choice Requires="a14">
           <p:sp>
             <p:nvSpPr>
               <p:cNvPr id="5" name="TextBox 4">
@@ -12353,7 +13425,7 @@
             </p:txBody>
           </p:sp>
         </mc:Choice>
-        <mc:Fallback>
+        <mc:Fallback xmlns="">
           <p:sp>
             <p:nvSpPr>
               <p:cNvPr id="5" name="TextBox 4">
@@ -13602,7 +14674,7 @@
         <p:spPr>
           <a:xfrm>
             <a:off x="958970" y="1759610"/>
-            <a:ext cx="6883400" cy="3693319"/>
+            <a:ext cx="6883400" cy="923330"/>
           </a:xfrm>
           <a:prstGeom prst="rect">
             <a:avLst/>
@@ -13623,7 +14695,7 @@
               <a:rPr lang="en-US" dirty="0">
                 <a:sym typeface="Wingdings" panose="05000000000000000000" pitchFamily="2" charset="2"/>
               </a:rPr>
-              <a:t>Operational: Speed &amp; Frequency</a:t>
+              <a:t>Inbound &amp; Outbound Traffic: Morning (5-7) x Evening (19-22) </a:t>
             </a:r>
           </a:p>
           <a:p>
@@ -13635,7 +14707,19 @@
               <a:rPr lang="en-US" dirty="0">
                 <a:sym typeface="Wingdings" panose="05000000000000000000" pitchFamily="2" charset="2"/>
               </a:rPr>
-              <a:t>Histogram (charts)</a:t>
+              <a:t>(DLR, </a:t>
+            </a:r>
+            <a:r>
+              <a:rPr lang="en-US" dirty="0" err="1">
+                <a:sym typeface="Wingdings" panose="05000000000000000000" pitchFamily="2" charset="2"/>
+              </a:rPr>
+              <a:t>OverGround</a:t>
+            </a:r>
+            <a:r>
+              <a:rPr lang="en-US" dirty="0">
+                <a:sym typeface="Wingdings" panose="05000000000000000000" pitchFamily="2" charset="2"/>
+              </a:rPr>
+              <a:t>, Tube) </a:t>
             </a:r>
           </a:p>
           <a:p>
@@ -13647,163 +14731,7 @@
               <a:rPr lang="en-US" dirty="0">
                 <a:sym typeface="Wingdings" panose="05000000000000000000" pitchFamily="2" charset="2"/>
               </a:rPr>
-              <a:t>Maps (Networkx)</a:t>
-            </a:r>
-          </a:p>
-          <a:p>
-            <a:pPr marL="0" indent="0">
-              <a:buFontTx/>
-              <a:buNone/>
-            </a:pPr>
-            <a:endParaRPr lang="en-US" dirty="0">
-              <a:sym typeface="Wingdings" panose="05000000000000000000" pitchFamily="2" charset="2"/>
-            </a:endParaRPr>
-          </a:p>
-          <a:p>
-            <a:pPr marL="0" marR="0" lvl="0" indent="0" algn="l" defTabSz="914400" rtl="0" eaLnBrk="1" fontAlgn="auto" latinLnBrk="0" hangingPunct="1">
-              <a:lnSpc>
-                <a:spcPct val="100000"/>
-              </a:lnSpc>
-              <a:spcBef>
-                <a:spcPts val="0"/>
-              </a:spcBef>
-              <a:spcAft>
-                <a:spcPts val="0"/>
-              </a:spcAft>
-              <a:buClrTx/>
-              <a:buSzTx/>
-              <a:buFontTx/>
-              <a:buNone/>
-              <a:tabLst/>
-              <a:defRPr/>
-            </a:pPr>
-            <a:r>
-              <a:rPr lang="en-US" dirty="0">
-                <a:sym typeface="Wingdings" panose="05000000000000000000" pitchFamily="2" charset="2"/>
-              </a:rPr>
-              <a:t> Traffic</a:t>
-            </a:r>
-          </a:p>
-          <a:p>
-            <a:pPr marL="171450" indent="-171450">
-              <a:buFontTx/>
-              <a:buChar char="-"/>
-            </a:pPr>
-            <a:r>
-              <a:rPr lang="en-US" dirty="0">
-                <a:sym typeface="Wingdings" panose="05000000000000000000" pitchFamily="2" charset="2"/>
-              </a:rPr>
-              <a:t>Enter/Exists in stations (Networkx)</a:t>
-            </a:r>
-          </a:p>
-          <a:p>
-            <a:pPr marL="171450" indent="-171450">
-              <a:buFontTx/>
-              <a:buChar char="-"/>
-            </a:pPr>
-            <a:r>
-              <a:rPr lang="en-US" dirty="0">
-                <a:sym typeface="Wingdings" panose="05000000000000000000" pitchFamily="2" charset="2"/>
-              </a:rPr>
-              <a:t>Load in segments (Networkx)</a:t>
-            </a:r>
-          </a:p>
-          <a:p>
-            <a:pPr marL="171450" indent="-171450">
-              <a:buFontTx/>
-              <a:buChar char="-"/>
-            </a:pPr>
-            <a:endParaRPr lang="en-US" dirty="0">
-              <a:sym typeface="Wingdings" panose="05000000000000000000" pitchFamily="2" charset="2"/>
-            </a:endParaRPr>
-          </a:p>
-          <a:p>
-            <a:pPr marL="0" marR="0" lvl="0" indent="0" algn="l" defTabSz="914400" rtl="0" eaLnBrk="1" fontAlgn="auto" latinLnBrk="0" hangingPunct="1">
-              <a:lnSpc>
-                <a:spcPct val="100000"/>
-              </a:lnSpc>
-              <a:spcBef>
-                <a:spcPts val="0"/>
-              </a:spcBef>
-              <a:spcAft>
-                <a:spcPts val="0"/>
-              </a:spcAft>
-              <a:buClrTx/>
-              <a:buSzTx/>
-              <a:buFontTx/>
-              <a:buNone/>
-              <a:tabLst/>
-              <a:defRPr/>
-            </a:pPr>
-            <a:r>
-              <a:rPr lang="en-US" dirty="0">
-                <a:sym typeface="Wingdings" panose="05000000000000000000" pitchFamily="2" charset="2"/>
-              </a:rPr>
-              <a:t> User importance:</a:t>
-            </a:r>
-          </a:p>
-          <a:p>
-            <a:pPr marL="171450" indent="-171450">
-              <a:buFontTx/>
-              <a:buChar char="-"/>
-            </a:pPr>
-            <a:r>
-              <a:rPr lang="en-US" dirty="0" err="1">
-                <a:sym typeface="Wingdings" panose="05000000000000000000" pitchFamily="2" charset="2"/>
-              </a:rPr>
-              <a:t>Efficience</a:t>
-            </a:r>
-            <a:r>
-              <a:rPr lang="en-US" dirty="0">
-                <a:sym typeface="Wingdings" panose="05000000000000000000" pitchFamily="2" charset="2"/>
-              </a:rPr>
-              <a:t> ranking comparison</a:t>
-            </a:r>
-          </a:p>
-          <a:p>
-            <a:pPr marL="171450" indent="-171450">
-              <a:buFontTx/>
-              <a:buChar char="-"/>
-            </a:pPr>
-            <a:endParaRPr lang="en-US" dirty="0">
-              <a:sym typeface="Wingdings" panose="05000000000000000000" pitchFamily="2" charset="2"/>
-            </a:endParaRPr>
-          </a:p>
-          <a:p>
-            <a:pPr marL="0" marR="0" lvl="0" indent="0" algn="l" defTabSz="914400" rtl="0" eaLnBrk="1" fontAlgn="auto" latinLnBrk="0" hangingPunct="1">
-              <a:lnSpc>
-                <a:spcPct val="100000"/>
-              </a:lnSpc>
-              <a:spcBef>
-                <a:spcPts val="0"/>
-              </a:spcBef>
-              <a:spcAft>
-                <a:spcPts val="0"/>
-              </a:spcAft>
-              <a:buClrTx/>
-              <a:buSzTx/>
-              <a:buFontTx/>
-              <a:buNone/>
-              <a:tabLst/>
-              <a:defRPr/>
-            </a:pPr>
-            <a:r>
-              <a:rPr lang="en-US" dirty="0">
-                <a:sym typeface="Wingdings" panose="05000000000000000000" pitchFamily="2" charset="2"/>
-              </a:rPr>
-              <a:t> Collective importance:</a:t>
-            </a:r>
-          </a:p>
-          <a:p>
-            <a:pPr marL="171450" indent="-171450">
-              <a:buFontTx/>
-              <a:buChar char="-"/>
-            </a:pPr>
-            <a:r>
-              <a:rPr lang="en-US" dirty="0">
-                <a:sym typeface="Wingdings" panose="05000000000000000000" pitchFamily="2" charset="2"/>
-              </a:rPr>
-              <a:t>Distress ranking comparison</a:t>
+              <a:t>MTT, FRI, SAT and SUN</a:t>
             </a:r>
           </a:p>
         </p:txBody>
@@ -13861,6 +14789,565 @@
           <a:p>
             <a:r>
               <a:rPr lang="en-US" dirty="0"/>
+              <a:t>Chp.5 - Results</a:t>
+            </a:r>
+            <a:endParaRPr lang="fr-BE" dirty="0"/>
+          </a:p>
+        </p:txBody>
+      </p:sp>
+      <p:sp>
+        <p:nvSpPr>
+          <p:cNvPr id="5" name="TextBox 4">
+            <a:extLst>
+              <a:ext uri="{FF2B5EF4-FFF2-40B4-BE49-F238E27FC236}">
+                <a16:creationId xmlns:a16="http://schemas.microsoft.com/office/drawing/2014/main" id="{1C70F5EB-D628-4D33-90C3-908BAEAACF37}"/>
+              </a:ext>
+            </a:extLst>
+          </p:cNvPr>
+          <p:cNvSpPr txBox="1"/>
+          <p:nvPr/>
+        </p:nvSpPr>
+        <p:spPr>
+          <a:xfrm>
+            <a:off x="958970" y="1759610"/>
+            <a:ext cx="6883400" cy="923330"/>
+          </a:xfrm>
+          <a:prstGeom prst="rect">
+            <a:avLst/>
+          </a:prstGeom>
+          <a:noFill/>
+        </p:spPr>
+        <p:txBody>
+          <a:bodyPr wrap="square">
+            <a:spAutoFit/>
+          </a:bodyPr>
+          <a:lstStyle/>
+          <a:p>
+            <a:pPr marL="0" marR="0" lvl="0" indent="0" algn="l" defTabSz="914400" rtl="0" eaLnBrk="1" fontAlgn="auto" latinLnBrk="0" hangingPunct="1">
+              <a:lnSpc>
+                <a:spcPct val="100000"/>
+              </a:lnSpc>
+              <a:spcBef>
+                <a:spcPts val="0"/>
+              </a:spcBef>
+              <a:spcAft>
+                <a:spcPts val="0"/>
+              </a:spcAft>
+              <a:buClrTx/>
+              <a:buSzTx/>
+              <a:buFontTx/>
+              <a:buNone/>
+              <a:tabLst/>
+              <a:defRPr/>
+            </a:pPr>
+            <a:r>
+              <a:rPr lang="en-US" dirty="0">
+                <a:sym typeface="Wingdings" panose="05000000000000000000" pitchFamily="2" charset="2"/>
+              </a:rPr>
+              <a:t> Traffic</a:t>
+            </a:r>
+          </a:p>
+          <a:p>
+            <a:pPr marL="171450" indent="-171450">
+              <a:buFontTx/>
+              <a:buChar char="-"/>
+            </a:pPr>
+            <a:r>
+              <a:rPr lang="en-US" dirty="0">
+                <a:sym typeface="Wingdings" panose="05000000000000000000" pitchFamily="2" charset="2"/>
+              </a:rPr>
+              <a:t>Enter/Exists in stations (Networkx)</a:t>
+            </a:r>
+          </a:p>
+          <a:p>
+            <a:pPr marL="171450" indent="-171450">
+              <a:buFontTx/>
+              <a:buChar char="-"/>
+            </a:pPr>
+            <a:r>
+              <a:rPr lang="en-US" dirty="0">
+                <a:sym typeface="Wingdings" panose="05000000000000000000" pitchFamily="2" charset="2"/>
+              </a:rPr>
+              <a:t>Load in segments (</a:t>
+            </a:r>
+            <a:r>
+              <a:rPr lang="en-US" dirty="0" err="1">
+                <a:sym typeface="Wingdings" panose="05000000000000000000" pitchFamily="2" charset="2"/>
+              </a:rPr>
+              <a:t>Networkx</a:t>
+            </a:r>
+            <a:r>
+              <a:rPr lang="en-US" dirty="0">
+                <a:sym typeface="Wingdings" panose="05000000000000000000" pitchFamily="2" charset="2"/>
+              </a:rPr>
+              <a:t>)</a:t>
+            </a:r>
+          </a:p>
+        </p:txBody>
+      </p:sp>
+    </p:spTree>
+    <p:extLst>
+      <p:ext uri="{BB962C8B-B14F-4D97-AF65-F5344CB8AC3E}">
+        <p14:creationId xmlns:p14="http://schemas.microsoft.com/office/powerpoint/2010/main" val="2043830219"/>
+      </p:ext>
+    </p:extLst>
+  </p:cSld>
+  <p:clrMapOvr>
+    <a:masterClrMapping/>
+  </p:clrMapOvr>
+</p:sld>
+</file>
+
+<file path=ppt/slides/slide23.xml><?xml version="1.0" encoding="utf-8"?>
+<p:sld xmlns:a="http://schemas.openxmlformats.org/drawingml/2006/main" xmlns:r="http://schemas.openxmlformats.org/officeDocument/2006/relationships" xmlns:p="http://schemas.openxmlformats.org/presentationml/2006/main">
+  <p:cSld>
+    <p:spTree>
+      <p:nvGrpSpPr>
+        <p:cNvPr id="1" name=""/>
+        <p:cNvGrpSpPr/>
+        <p:nvPr/>
+      </p:nvGrpSpPr>
+      <p:grpSpPr>
+        <a:xfrm>
+          <a:off x="0" y="0"/>
+          <a:ext cx="0" cy="0"/>
+          <a:chOff x="0" y="0"/>
+          <a:chExt cx="0" cy="0"/>
+        </a:xfrm>
+      </p:grpSpPr>
+      <p:sp>
+        <p:nvSpPr>
+          <p:cNvPr id="2" name="Title 1">
+            <a:extLst>
+              <a:ext uri="{FF2B5EF4-FFF2-40B4-BE49-F238E27FC236}">
+                <a16:creationId xmlns:a16="http://schemas.microsoft.com/office/drawing/2014/main" id="{63482FFF-7EC4-4691-BF8C-91E0066F6BE9}"/>
+              </a:ext>
+            </a:extLst>
+          </p:cNvPr>
+          <p:cNvSpPr>
+            <a:spLocks noGrp="1"/>
+          </p:cNvSpPr>
+          <p:nvPr>
+            <p:ph type="title"/>
+          </p:nvPr>
+        </p:nvSpPr>
+        <p:spPr/>
+        <p:txBody>
+          <a:bodyPr/>
+          <a:lstStyle/>
+          <a:p>
+            <a:r>
+              <a:rPr lang="en-US" dirty="0"/>
+              <a:t>Chp.5 - Results</a:t>
+            </a:r>
+            <a:endParaRPr lang="fr-BE" dirty="0"/>
+          </a:p>
+        </p:txBody>
+      </p:sp>
+      <p:sp>
+        <p:nvSpPr>
+          <p:cNvPr id="5" name="TextBox 4">
+            <a:extLst>
+              <a:ext uri="{FF2B5EF4-FFF2-40B4-BE49-F238E27FC236}">
+                <a16:creationId xmlns:a16="http://schemas.microsoft.com/office/drawing/2014/main" id="{1C70F5EB-D628-4D33-90C3-908BAEAACF37}"/>
+              </a:ext>
+            </a:extLst>
+          </p:cNvPr>
+          <p:cNvSpPr txBox="1"/>
+          <p:nvPr/>
+        </p:nvSpPr>
+        <p:spPr>
+          <a:xfrm>
+            <a:off x="958970" y="1759610"/>
+            <a:ext cx="6883400" cy="1200329"/>
+          </a:xfrm>
+          <a:prstGeom prst="rect">
+            <a:avLst/>
+          </a:prstGeom>
+          <a:noFill/>
+        </p:spPr>
+        <p:txBody>
+          <a:bodyPr wrap="square">
+            <a:spAutoFit/>
+          </a:bodyPr>
+          <a:lstStyle/>
+          <a:p>
+            <a:pPr marL="171450" indent="-171450">
+              <a:buFont typeface="Wingdings" panose="05000000000000000000" pitchFamily="2" charset="2"/>
+              <a:buChar char="à"/>
+            </a:pPr>
+            <a:r>
+              <a:rPr lang="en-US" dirty="0">
+                <a:sym typeface="Wingdings" panose="05000000000000000000" pitchFamily="2" charset="2"/>
+              </a:rPr>
+              <a:t>Operational: Speed &amp; Frequency</a:t>
+            </a:r>
+          </a:p>
+          <a:p>
+            <a:pPr marL="171450" indent="-171450">
+              <a:buFontTx/>
+              <a:buChar char="-"/>
+            </a:pPr>
+            <a:r>
+              <a:rPr lang="en-US" dirty="0">
+                <a:sym typeface="Wingdings" panose="05000000000000000000" pitchFamily="2" charset="2"/>
+              </a:rPr>
+              <a:t>Histogram (charts)</a:t>
+            </a:r>
+          </a:p>
+          <a:p>
+            <a:pPr marL="171450" indent="-171450">
+              <a:buFontTx/>
+              <a:buChar char="-"/>
+            </a:pPr>
+            <a:r>
+              <a:rPr lang="en-US" dirty="0">
+                <a:sym typeface="Wingdings" panose="05000000000000000000" pitchFamily="2" charset="2"/>
+              </a:rPr>
+              <a:t>Maps (</a:t>
+            </a:r>
+            <a:r>
+              <a:rPr lang="en-US" dirty="0" err="1">
+                <a:sym typeface="Wingdings" panose="05000000000000000000" pitchFamily="2" charset="2"/>
+              </a:rPr>
+              <a:t>Networkx</a:t>
+            </a:r>
+            <a:r>
+              <a:rPr lang="en-US" dirty="0">
+                <a:sym typeface="Wingdings" panose="05000000000000000000" pitchFamily="2" charset="2"/>
+              </a:rPr>
+              <a:t>)</a:t>
+            </a:r>
+          </a:p>
+          <a:p>
+            <a:pPr marL="0" indent="0">
+              <a:buFontTx/>
+              <a:buNone/>
+            </a:pPr>
+            <a:endParaRPr lang="en-US" dirty="0">
+              <a:sym typeface="Wingdings" panose="05000000000000000000" pitchFamily="2" charset="2"/>
+            </a:endParaRPr>
+          </a:p>
+        </p:txBody>
+      </p:sp>
+    </p:spTree>
+    <p:extLst>
+      <p:ext uri="{BB962C8B-B14F-4D97-AF65-F5344CB8AC3E}">
+        <p14:creationId xmlns:p14="http://schemas.microsoft.com/office/powerpoint/2010/main" val="468144026"/>
+      </p:ext>
+    </p:extLst>
+  </p:cSld>
+  <p:clrMapOvr>
+    <a:masterClrMapping/>
+  </p:clrMapOvr>
+</p:sld>
+</file>
+
+<file path=ppt/slides/slide24.xml><?xml version="1.0" encoding="utf-8"?>
+<p:sld xmlns:a="http://schemas.openxmlformats.org/drawingml/2006/main" xmlns:r="http://schemas.openxmlformats.org/officeDocument/2006/relationships" xmlns:p="http://schemas.openxmlformats.org/presentationml/2006/main">
+  <p:cSld>
+    <p:spTree>
+      <p:nvGrpSpPr>
+        <p:cNvPr id="1" name=""/>
+        <p:cNvGrpSpPr/>
+        <p:nvPr/>
+      </p:nvGrpSpPr>
+      <p:grpSpPr>
+        <a:xfrm>
+          <a:off x="0" y="0"/>
+          <a:ext cx="0" cy="0"/>
+          <a:chOff x="0" y="0"/>
+          <a:chExt cx="0" cy="0"/>
+        </a:xfrm>
+      </p:grpSpPr>
+      <p:sp>
+        <p:nvSpPr>
+          <p:cNvPr id="2" name="Title 1">
+            <a:extLst>
+              <a:ext uri="{FF2B5EF4-FFF2-40B4-BE49-F238E27FC236}">
+                <a16:creationId xmlns:a16="http://schemas.microsoft.com/office/drawing/2014/main" id="{63482FFF-7EC4-4691-BF8C-91E0066F6BE9}"/>
+              </a:ext>
+            </a:extLst>
+          </p:cNvPr>
+          <p:cNvSpPr>
+            <a:spLocks noGrp="1"/>
+          </p:cNvSpPr>
+          <p:nvPr>
+            <p:ph type="title"/>
+          </p:nvPr>
+        </p:nvSpPr>
+        <p:spPr/>
+        <p:txBody>
+          <a:bodyPr/>
+          <a:lstStyle/>
+          <a:p>
+            <a:r>
+              <a:rPr lang="en-US" dirty="0"/>
+              <a:t>Chp.5 - Results</a:t>
+            </a:r>
+            <a:endParaRPr lang="fr-BE" dirty="0"/>
+          </a:p>
+        </p:txBody>
+      </p:sp>
+      <p:sp>
+        <p:nvSpPr>
+          <p:cNvPr id="5" name="TextBox 4">
+            <a:extLst>
+              <a:ext uri="{FF2B5EF4-FFF2-40B4-BE49-F238E27FC236}">
+                <a16:creationId xmlns:a16="http://schemas.microsoft.com/office/drawing/2014/main" id="{1C70F5EB-D628-4D33-90C3-908BAEAACF37}"/>
+              </a:ext>
+            </a:extLst>
+          </p:cNvPr>
+          <p:cNvSpPr txBox="1"/>
+          <p:nvPr/>
+        </p:nvSpPr>
+        <p:spPr>
+          <a:xfrm>
+            <a:off x="958970" y="1759610"/>
+            <a:ext cx="6883400" cy="923330"/>
+          </a:xfrm>
+          <a:prstGeom prst="rect">
+            <a:avLst/>
+          </a:prstGeom>
+          <a:noFill/>
+        </p:spPr>
+        <p:txBody>
+          <a:bodyPr wrap="square">
+            <a:spAutoFit/>
+          </a:bodyPr>
+          <a:lstStyle/>
+          <a:p>
+            <a:pPr marL="0" marR="0" lvl="0" indent="0" algn="l" defTabSz="914400" rtl="0" eaLnBrk="1" fontAlgn="auto" latinLnBrk="0" hangingPunct="1">
+              <a:lnSpc>
+                <a:spcPct val="100000"/>
+              </a:lnSpc>
+              <a:spcBef>
+                <a:spcPts val="0"/>
+              </a:spcBef>
+              <a:spcAft>
+                <a:spcPts val="0"/>
+              </a:spcAft>
+              <a:buClrTx/>
+              <a:buSzTx/>
+              <a:buFontTx/>
+              <a:buNone/>
+              <a:tabLst/>
+              <a:defRPr/>
+            </a:pPr>
+            <a:r>
+              <a:rPr lang="en-US" dirty="0">
+                <a:sym typeface="Wingdings" panose="05000000000000000000" pitchFamily="2" charset="2"/>
+              </a:rPr>
+              <a:t> User importance:</a:t>
+            </a:r>
+          </a:p>
+          <a:p>
+            <a:pPr marL="171450" indent="-171450">
+              <a:buFontTx/>
+              <a:buChar char="-"/>
+            </a:pPr>
+            <a:r>
+              <a:rPr lang="en-US" dirty="0" err="1">
+                <a:sym typeface="Wingdings" panose="05000000000000000000" pitchFamily="2" charset="2"/>
+              </a:rPr>
+              <a:t>Efficience</a:t>
+            </a:r>
+            <a:r>
+              <a:rPr lang="en-US" dirty="0">
+                <a:sym typeface="Wingdings" panose="05000000000000000000" pitchFamily="2" charset="2"/>
+              </a:rPr>
+              <a:t> ranking comparison</a:t>
+            </a:r>
+          </a:p>
+          <a:p>
+            <a:pPr marL="171450" indent="-171450">
+              <a:buFontTx/>
+              <a:buChar char="-"/>
+            </a:pPr>
+            <a:endParaRPr lang="en-US" dirty="0">
+              <a:sym typeface="Wingdings" panose="05000000000000000000" pitchFamily="2" charset="2"/>
+            </a:endParaRPr>
+          </a:p>
+        </p:txBody>
+      </p:sp>
+    </p:spTree>
+    <p:extLst>
+      <p:ext uri="{BB962C8B-B14F-4D97-AF65-F5344CB8AC3E}">
+        <p14:creationId xmlns:p14="http://schemas.microsoft.com/office/powerpoint/2010/main" val="2555179648"/>
+      </p:ext>
+    </p:extLst>
+  </p:cSld>
+  <p:clrMapOvr>
+    <a:masterClrMapping/>
+  </p:clrMapOvr>
+</p:sld>
+</file>
+
+<file path=ppt/slides/slide25.xml><?xml version="1.0" encoding="utf-8"?>
+<p:sld xmlns:a="http://schemas.openxmlformats.org/drawingml/2006/main" xmlns:r="http://schemas.openxmlformats.org/officeDocument/2006/relationships" xmlns:p="http://schemas.openxmlformats.org/presentationml/2006/main">
+  <p:cSld>
+    <p:spTree>
+      <p:nvGrpSpPr>
+        <p:cNvPr id="1" name=""/>
+        <p:cNvGrpSpPr/>
+        <p:nvPr/>
+      </p:nvGrpSpPr>
+      <p:grpSpPr>
+        <a:xfrm>
+          <a:off x="0" y="0"/>
+          <a:ext cx="0" cy="0"/>
+          <a:chOff x="0" y="0"/>
+          <a:chExt cx="0" cy="0"/>
+        </a:xfrm>
+      </p:grpSpPr>
+      <p:sp>
+        <p:nvSpPr>
+          <p:cNvPr id="2" name="Title 1">
+            <a:extLst>
+              <a:ext uri="{FF2B5EF4-FFF2-40B4-BE49-F238E27FC236}">
+                <a16:creationId xmlns:a16="http://schemas.microsoft.com/office/drawing/2014/main" id="{63482FFF-7EC4-4691-BF8C-91E0066F6BE9}"/>
+              </a:ext>
+            </a:extLst>
+          </p:cNvPr>
+          <p:cNvSpPr>
+            <a:spLocks noGrp="1"/>
+          </p:cNvSpPr>
+          <p:nvPr>
+            <p:ph type="title"/>
+          </p:nvPr>
+        </p:nvSpPr>
+        <p:spPr/>
+        <p:txBody>
+          <a:bodyPr/>
+          <a:lstStyle/>
+          <a:p>
+            <a:r>
+              <a:rPr lang="en-US" dirty="0"/>
+              <a:t>Chp.5 - Results</a:t>
+            </a:r>
+            <a:endParaRPr lang="fr-BE" dirty="0"/>
+          </a:p>
+        </p:txBody>
+      </p:sp>
+      <p:sp>
+        <p:nvSpPr>
+          <p:cNvPr id="5" name="TextBox 4">
+            <a:extLst>
+              <a:ext uri="{FF2B5EF4-FFF2-40B4-BE49-F238E27FC236}">
+                <a16:creationId xmlns:a16="http://schemas.microsoft.com/office/drawing/2014/main" id="{1C70F5EB-D628-4D33-90C3-908BAEAACF37}"/>
+              </a:ext>
+            </a:extLst>
+          </p:cNvPr>
+          <p:cNvSpPr txBox="1"/>
+          <p:nvPr/>
+        </p:nvSpPr>
+        <p:spPr>
+          <a:xfrm>
+            <a:off x="958970" y="1759610"/>
+            <a:ext cx="6883400" cy="646331"/>
+          </a:xfrm>
+          <a:prstGeom prst="rect">
+            <a:avLst/>
+          </a:prstGeom>
+          <a:noFill/>
+        </p:spPr>
+        <p:txBody>
+          <a:bodyPr wrap="square">
+            <a:spAutoFit/>
+          </a:bodyPr>
+          <a:lstStyle/>
+          <a:p>
+            <a:pPr marL="0" marR="0" lvl="0" indent="0" algn="l" defTabSz="914400" rtl="0" eaLnBrk="1" fontAlgn="auto" latinLnBrk="0" hangingPunct="1">
+              <a:lnSpc>
+                <a:spcPct val="100000"/>
+              </a:lnSpc>
+              <a:spcBef>
+                <a:spcPts val="0"/>
+              </a:spcBef>
+              <a:spcAft>
+                <a:spcPts val="0"/>
+              </a:spcAft>
+              <a:buClrTx/>
+              <a:buSzTx/>
+              <a:buFontTx/>
+              <a:buNone/>
+              <a:tabLst/>
+              <a:defRPr/>
+            </a:pPr>
+            <a:r>
+              <a:rPr lang="en-US" dirty="0">
+                <a:sym typeface="Wingdings" panose="05000000000000000000" pitchFamily="2" charset="2"/>
+              </a:rPr>
+              <a:t> Collective importance:</a:t>
+            </a:r>
+          </a:p>
+          <a:p>
+            <a:pPr marL="171450" indent="-171450">
+              <a:buFontTx/>
+              <a:buChar char="-"/>
+            </a:pPr>
+            <a:r>
+              <a:rPr lang="en-US" dirty="0">
+                <a:sym typeface="Wingdings" panose="05000000000000000000" pitchFamily="2" charset="2"/>
+              </a:rPr>
+              <a:t>Distress ranking comparison</a:t>
+            </a:r>
+          </a:p>
+        </p:txBody>
+      </p:sp>
+    </p:spTree>
+    <p:extLst>
+      <p:ext uri="{BB962C8B-B14F-4D97-AF65-F5344CB8AC3E}">
+        <p14:creationId xmlns:p14="http://schemas.microsoft.com/office/powerpoint/2010/main" val="2702504304"/>
+      </p:ext>
+    </p:extLst>
+  </p:cSld>
+  <p:clrMapOvr>
+    <a:masterClrMapping/>
+  </p:clrMapOvr>
+</p:sld>
+</file>
+
+<file path=ppt/slides/slide26.xml><?xml version="1.0" encoding="utf-8"?>
+<p:sld xmlns:a="http://schemas.openxmlformats.org/drawingml/2006/main" xmlns:r="http://schemas.openxmlformats.org/officeDocument/2006/relationships" xmlns:p="http://schemas.openxmlformats.org/presentationml/2006/main">
+  <p:cSld>
+    <p:spTree>
+      <p:nvGrpSpPr>
+        <p:cNvPr id="1" name=""/>
+        <p:cNvGrpSpPr/>
+        <p:nvPr/>
+      </p:nvGrpSpPr>
+      <p:grpSpPr>
+        <a:xfrm>
+          <a:off x="0" y="0"/>
+          <a:ext cx="0" cy="0"/>
+          <a:chOff x="0" y="0"/>
+          <a:chExt cx="0" cy="0"/>
+        </a:xfrm>
+      </p:grpSpPr>
+      <p:sp>
+        <p:nvSpPr>
+          <p:cNvPr id="2" name="Title 1">
+            <a:extLst>
+              <a:ext uri="{FF2B5EF4-FFF2-40B4-BE49-F238E27FC236}">
+                <a16:creationId xmlns:a16="http://schemas.microsoft.com/office/drawing/2014/main" id="{63482FFF-7EC4-4691-BF8C-91E0066F6BE9}"/>
+              </a:ext>
+            </a:extLst>
+          </p:cNvPr>
+          <p:cNvSpPr>
+            <a:spLocks noGrp="1"/>
+          </p:cNvSpPr>
+          <p:nvPr>
+            <p:ph type="title"/>
+          </p:nvPr>
+        </p:nvSpPr>
+        <p:spPr/>
+        <p:txBody>
+          <a:bodyPr/>
+          <a:lstStyle/>
+          <a:p>
+            <a:r>
+              <a:rPr lang="en-US" dirty="0"/>
               <a:t>Chp.6 - Following Steps</a:t>
             </a:r>
             <a:endParaRPr lang="fr-BE" dirty="0"/>
@@ -14086,7 +15573,7 @@
 </p:sld>
 </file>
 
-<file path=ppt/slides/slide23.xml><?xml version="1.0" encoding="utf-8"?>
+<file path=ppt/slides/slide27.xml><?xml version="1.0" encoding="utf-8"?>
 <p:sld xmlns:a="http://schemas.openxmlformats.org/drawingml/2006/main" xmlns:r="http://schemas.openxmlformats.org/officeDocument/2006/relationships" xmlns:p="http://schemas.openxmlformats.org/presentationml/2006/main">
   <p:cSld>
     <p:spTree>

</xml_diff>